<commit_message>
Update course defense materials
</commit_message>
<xml_diff>
--- a/第24组_课程答辩.pptx
+++ b/第24组_课程答辩.pptx
@@ -3890,7 +3890,42 @@
       </p:sp>
       <p:sp>
         <p:nvSpPr>
-          <p:cNvPr id="7" name="Rectangle 6"/>
+          <p:cNvPr id="7" name="TextBox 6"/>
+          <p:cNvSpPr txBox="1"/>
+          <p:nvPr/>
+        </p:nvSpPr>
+        <p:spPr>
+          <a:xfrm>
+            <a:off x="1519200" y="2851200"/>
+            <a:ext cx="5400000" cy="162000"/>
+          </a:xfrm>
+          <a:prstGeom prst="rect">
+            <a:avLst/>
+          </a:prstGeom>
+          <a:noFill/>
+        </p:spPr>
+        <p:txBody>
+          <a:bodyPr wrap="square" lIns="0" tIns="0" rIns="0" bIns="0" anchor="t">
+            <a:spAutoFit/>
+          </a:bodyPr>
+          <a:lstStyle/>
+          <a:p>
+            <a:pPr algn="l"/>
+            <a:r>
+              <a:rPr sz="969" b="1">
+                <a:solidFill>
+                  <a:srgbClr val="737373"/>
+                </a:solidFill>
+                <a:latin typeface="Microsoft YaHei"/>
+              </a:rPr>
+              <a:t>内容主线：光谱问题 → 数据建模 → LED 补偿应用</a:t>
+            </a:r>
+          </a:p>
+        </p:txBody>
+      </p:sp>
+      <p:sp>
+        <p:nvSpPr>
+          <p:cNvPr id="8" name="Rectangle 7"/>
           <p:cNvSpPr/>
           <p:nvPr/>
         </p:nvSpPr>
@@ -3933,7 +3968,7 @@
       </p:sp>
       <p:sp>
         <p:nvSpPr>
-          <p:cNvPr id="8" name="TextBox 7"/>
+          <p:cNvPr id="9" name="TextBox 8"/>
           <p:cNvSpPr txBox="1"/>
           <p:nvPr/>
         </p:nvSpPr>
@@ -3968,7 +4003,7 @@
       </p:sp>
       <p:sp>
         <p:nvSpPr>
-          <p:cNvPr id="9" name="TextBox 8"/>
+          <p:cNvPr id="10" name="TextBox 9"/>
           <p:cNvSpPr txBox="1"/>
           <p:nvPr/>
         </p:nvSpPr>
@@ -4003,7 +4038,7 @@
       </p:sp>
       <p:sp>
         <p:nvSpPr>
-          <p:cNvPr id="10" name="TextBox 9"/>
+          <p:cNvPr id="11" name="TextBox 10"/>
           <p:cNvSpPr txBox="1"/>
           <p:nvPr/>
         </p:nvSpPr>
@@ -4038,7 +4073,7 @@
       </p:sp>
       <p:sp>
         <p:nvSpPr>
-          <p:cNvPr id="11" name="TextBox 10"/>
+          <p:cNvPr id="12" name="TextBox 11"/>
           <p:cNvSpPr txBox="1"/>
           <p:nvPr/>
         </p:nvSpPr>
@@ -4073,7 +4108,7 @@
       </p:sp>
       <p:sp>
         <p:nvSpPr>
-          <p:cNvPr id="12" name="TextBox 11"/>
+          <p:cNvPr id="13" name="TextBox 12"/>
           <p:cNvSpPr txBox="1"/>
           <p:nvPr/>
         </p:nvSpPr>
@@ -4108,7 +4143,7 @@
       </p:sp>
       <p:sp>
         <p:nvSpPr>
-          <p:cNvPr id="13" name="TextBox 12"/>
+          <p:cNvPr id="14" name="TextBox 13"/>
           <p:cNvSpPr txBox="1"/>
           <p:nvPr/>
         </p:nvSpPr>
@@ -4141,9 +4176,243 @@
           </a:p>
         </p:txBody>
       </p:sp>
+      <p:sp>
+        <p:nvSpPr>
+          <p:cNvPr id="15" name="Rectangle 14"/>
+          <p:cNvSpPr/>
+          <p:nvPr/>
+        </p:nvSpPr>
+        <p:spPr>
+          <a:xfrm>
+            <a:off x="1512000" y="4086000"/>
+            <a:ext cx="4050000" cy="846000"/>
+          </a:xfrm>
+          <a:prstGeom prst="rect">
+            <a:avLst/>
+          </a:prstGeom>
+          <a:solidFill>
+            <a:srgbClr val="F0F0EE"/>
+          </a:solidFill>
+          <a:ln>
+            <a:noFill/>
+          </a:ln>
+        </p:spPr>
+        <p:style>
+          <a:lnRef idx="1">
+            <a:schemeClr val="accent1"/>
+          </a:lnRef>
+          <a:fillRef idx="3">
+            <a:schemeClr val="accent1"/>
+          </a:fillRef>
+          <a:effectRef idx="2">
+            <a:schemeClr val="accent1"/>
+          </a:effectRef>
+          <a:fontRef idx="minor">
+            <a:schemeClr val="lt1"/>
+          </a:fontRef>
+        </p:style>
+        <p:txBody>
+          <a:bodyPr rtlCol="0" anchor="ctr"/>
+          <a:lstStyle/>
+          <a:p>
+            <a:pPr algn="ctr"/>
+          </a:p>
+        </p:txBody>
+      </p:sp>
+      <p:sp>
+        <p:nvSpPr>
+          <p:cNvPr id="16" name="TextBox 15"/>
+          <p:cNvSpPr txBox="1"/>
+          <p:nvPr/>
+        </p:nvSpPr>
+        <p:spPr>
+          <a:xfrm>
+            <a:off x="1638000" y="4176000"/>
+            <a:ext cx="3798000" cy="122400"/>
+          </a:xfrm>
+          <a:prstGeom prst="rect">
+            <a:avLst/>
+          </a:prstGeom>
+          <a:noFill/>
+        </p:spPr>
+        <p:txBody>
+          <a:bodyPr wrap="square" lIns="0" tIns="0" rIns="0" bIns="0" anchor="t">
+            <a:spAutoFit/>
+          </a:bodyPr>
+          <a:lstStyle/>
+          <a:p>
+            <a:pPr algn="l"/>
+            <a:r>
+              <a:rPr sz="940" b="1">
+                <a:solidFill>
+                  <a:srgbClr val="002FA7"/>
+                </a:solidFill>
+                <a:latin typeface="Microsoft YaHei"/>
+              </a:rPr>
+              <a:t>内容概览</a:t>
+            </a:r>
+          </a:p>
+        </p:txBody>
+      </p:sp>
+      <p:sp>
+        <p:nvSpPr>
+          <p:cNvPr id="17" name="TextBox 16"/>
+          <p:cNvSpPr txBox="1"/>
+          <p:nvPr/>
+        </p:nvSpPr>
+        <p:spPr>
+          <a:xfrm>
+            <a:off x="1638000" y="4366800"/>
+            <a:ext cx="3798000" cy="514800"/>
+          </a:xfrm>
+          <a:prstGeom prst="rect">
+            <a:avLst/>
+          </a:prstGeom>
+          <a:noFill/>
+        </p:spPr>
+        <p:txBody>
+          <a:bodyPr wrap="square" lIns="0" tIns="0" rIns="0" bIns="0" anchor="t">
+            <a:spAutoFit/>
+          </a:bodyPr>
+          <a:lstStyle/>
+          <a:p>
+            <a:pPr algn="l">
+              <a:lnSpc>
+                <a:spcPct val="103000"/>
+              </a:lnSpc>
+            </a:pPr>
+            <a:r>
+              <a:rPr sz="869" b="0">
+                <a:solidFill>
+                  <a:srgbClr val="0A0A0A"/>
+                </a:solidFill>
+                <a:latin typeface="Microsoft YaHei"/>
+              </a:rPr>
+              <a:t>本项目先说明为什么亮度和色温不足以描述照明质量，再说明如何用真实数据训练模型，最后展示预测光谱怎样进入 LED 补偿应用。</a:t>
+            </a:r>
+          </a:p>
+        </p:txBody>
+      </p:sp>
+      <p:sp>
+        <p:nvSpPr>
+          <p:cNvPr id="18" name="Rectangle 17"/>
+          <p:cNvSpPr/>
+          <p:nvPr/>
+        </p:nvSpPr>
+        <p:spPr>
+          <a:xfrm>
+            <a:off x="1512000" y="5076000"/>
+            <a:ext cx="4050000" cy="810000"/>
+          </a:xfrm>
+          <a:prstGeom prst="rect">
+            <a:avLst/>
+          </a:prstGeom>
+          <a:solidFill>
+            <a:srgbClr val="FAFAF8"/>
+          </a:solidFill>
+          <a:ln>
+            <a:noFill/>
+          </a:ln>
+        </p:spPr>
+        <p:style>
+          <a:lnRef idx="1">
+            <a:schemeClr val="accent1"/>
+          </a:lnRef>
+          <a:fillRef idx="3">
+            <a:schemeClr val="accent1"/>
+          </a:fillRef>
+          <a:effectRef idx="2">
+            <a:schemeClr val="accent1"/>
+          </a:effectRef>
+          <a:fontRef idx="minor">
+            <a:schemeClr val="lt1"/>
+          </a:fontRef>
+        </p:style>
+        <p:txBody>
+          <a:bodyPr rtlCol="0" anchor="ctr"/>
+          <a:lstStyle/>
+          <a:p>
+            <a:pPr algn="ctr"/>
+          </a:p>
+        </p:txBody>
+      </p:sp>
+      <p:sp>
+        <p:nvSpPr>
+          <p:cNvPr id="19" name="TextBox 18"/>
+          <p:cNvSpPr txBox="1"/>
+          <p:nvPr/>
+        </p:nvSpPr>
+        <p:spPr>
+          <a:xfrm>
+            <a:off x="1638000" y="5166000"/>
+            <a:ext cx="3798000" cy="122400"/>
+          </a:xfrm>
+          <a:prstGeom prst="rect">
+            <a:avLst/>
+          </a:prstGeom>
+          <a:noFill/>
+        </p:spPr>
+        <p:txBody>
+          <a:bodyPr wrap="square" lIns="0" tIns="0" rIns="0" bIns="0" anchor="t">
+            <a:spAutoFit/>
+          </a:bodyPr>
+          <a:lstStyle/>
+          <a:p>
+            <a:pPr algn="l"/>
+            <a:r>
+              <a:rPr sz="940" b="1">
+                <a:solidFill>
+                  <a:srgbClr val="002FA7"/>
+                </a:solidFill>
+                <a:latin typeface="Microsoft YaHei"/>
+              </a:rPr>
+              <a:t>项目定位</a:t>
+            </a:r>
+          </a:p>
+        </p:txBody>
+      </p:sp>
+      <p:sp>
+        <p:nvSpPr>
+          <p:cNvPr id="20" name="TextBox 19"/>
+          <p:cNvSpPr txBox="1"/>
+          <p:nvPr/>
+        </p:nvSpPr>
+        <p:spPr>
+          <a:xfrm>
+            <a:off x="1638000" y="5356800"/>
+            <a:ext cx="3798000" cy="478800"/>
+          </a:xfrm>
+          <a:prstGeom prst="rect">
+            <a:avLst/>
+          </a:prstGeom>
+          <a:noFill/>
+        </p:spPr>
+        <p:txBody>
+          <a:bodyPr wrap="square" lIns="0" tIns="0" rIns="0" bIns="0" anchor="t">
+            <a:spAutoFit/>
+          </a:bodyPr>
+          <a:lstStyle/>
+          <a:p>
+            <a:pPr algn="l">
+              <a:lnSpc>
+                <a:spcPct val="103000"/>
+              </a:lnSpc>
+            </a:pPr>
+            <a:r>
+              <a:rPr sz="869" b="0">
+                <a:solidFill>
+                  <a:srgbClr val="0A0A0A"/>
+                </a:solidFill>
+                <a:latin typeface="Microsoft YaHei"/>
+              </a:rPr>
+              <a:t>本项目是课程设计中的算法原型，重点展示 Python 数据处理、PCA 降维、模型对比和可视化结果，不把它夸大为已经落地的硬件系统。</a:t>
+            </a:r>
+          </a:p>
+        </p:txBody>
+      </p:sp>
       <p:pic>
         <p:nvPicPr>
-          <p:cNvPr id="14" name="Picture 13" descr="base_spectrum.png"/>
+          <p:cNvPr id="21" name="Picture 20" descr="base_spectrum.png"/>
           <p:cNvPicPr>
             <a:picLocks noChangeAspect="1"/>
           </p:cNvPicPr>
@@ -4167,7 +4436,7 @@
       </p:pic>
       <p:sp>
         <p:nvSpPr>
-          <p:cNvPr id="15" name="TextBox 14"/>
+          <p:cNvPr id="22" name="TextBox 21"/>
           <p:cNvSpPr txBox="1"/>
           <p:nvPr/>
         </p:nvSpPr>
@@ -4202,7 +4471,7 @@
       </p:sp>
       <p:sp>
         <p:nvSpPr>
-          <p:cNvPr id="16" name="TextBox 15"/>
+          <p:cNvPr id="23" name="TextBox 22"/>
           <p:cNvSpPr txBox="1"/>
           <p:nvPr/>
         </p:nvSpPr>
@@ -5132,6 +5401,123 @@
         </p:nvSpPr>
         <p:spPr>
           <a:xfrm>
+            <a:off x="360000" y="5112000"/>
+            <a:ext cx="10836000" cy="378000"/>
+          </a:xfrm>
+          <a:prstGeom prst="rect">
+            <a:avLst/>
+          </a:prstGeom>
+          <a:solidFill>
+            <a:srgbClr val="F0F0EE"/>
+          </a:solidFill>
+          <a:ln>
+            <a:noFill/>
+          </a:ln>
+        </p:spPr>
+        <p:style>
+          <a:lnRef idx="1">
+            <a:schemeClr val="accent1"/>
+          </a:lnRef>
+          <a:fillRef idx="3">
+            <a:schemeClr val="accent1"/>
+          </a:fillRef>
+          <a:effectRef idx="2">
+            <a:schemeClr val="accent1"/>
+          </a:effectRef>
+          <a:fontRef idx="minor">
+            <a:schemeClr val="lt1"/>
+          </a:fontRef>
+        </p:style>
+        <p:txBody>
+          <a:bodyPr rtlCol="0" anchor="ctr"/>
+          <a:lstStyle/>
+          <a:p>
+            <a:pPr algn="ctr"/>
+          </a:p>
+        </p:txBody>
+      </p:sp>
+      <p:sp>
+        <p:nvSpPr>
+          <p:cNvPr id="22" name="TextBox 21"/>
+          <p:cNvSpPr txBox="1"/>
+          <p:nvPr/>
+        </p:nvSpPr>
+        <p:spPr>
+          <a:xfrm>
+            <a:off x="486000" y="5202000"/>
+            <a:ext cx="10584000" cy="122400"/>
+          </a:xfrm>
+          <a:prstGeom prst="rect">
+            <a:avLst/>
+          </a:prstGeom>
+          <a:noFill/>
+        </p:spPr>
+        <p:txBody>
+          <a:bodyPr wrap="square" lIns="0" tIns="0" rIns="0" bIns="0" anchor="t">
+            <a:spAutoFit/>
+          </a:bodyPr>
+          <a:lstStyle/>
+          <a:p>
+            <a:pPr algn="l"/>
+            <a:r>
+              <a:rPr sz="940" b="1">
+                <a:solidFill>
+                  <a:srgbClr val="002FA7"/>
+                </a:solidFill>
+                <a:latin typeface="Microsoft YaHei"/>
+              </a:rPr>
+              <a:t>项目总结</a:t>
+            </a:r>
+          </a:p>
+        </p:txBody>
+      </p:sp>
+      <p:sp>
+        <p:nvSpPr>
+          <p:cNvPr id="23" name="TextBox 22"/>
+          <p:cNvSpPr txBox="1"/>
+          <p:nvPr/>
+        </p:nvSpPr>
+        <p:spPr>
+          <a:xfrm>
+            <a:off x="486000" y="5392799"/>
+            <a:ext cx="10584000" cy="46800"/>
+          </a:xfrm>
+          <a:prstGeom prst="rect">
+            <a:avLst/>
+          </a:prstGeom>
+          <a:noFill/>
+        </p:spPr>
+        <p:txBody>
+          <a:bodyPr wrap="square" lIns="0" tIns="0" rIns="0" bIns="0" anchor="t">
+            <a:spAutoFit/>
+          </a:bodyPr>
+          <a:lstStyle/>
+          <a:p>
+            <a:pPr algn="l">
+              <a:lnSpc>
+                <a:spcPct val="103000"/>
+              </a:lnSpc>
+            </a:pPr>
+            <a:r>
+              <a:rPr sz="869" b="0">
+                <a:solidFill>
+                  <a:srgbClr val="0A0A0A"/>
+                </a:solidFill>
+                <a:latin typeface="Microsoft YaHei"/>
+              </a:rPr>
+              <a:t>本项目是一个完整但谨慎的课程项目：数据是真实的，流程是可复现的，结果能进入应用演示；同时也承认样本、同步天气和硬件验证上的不足。</a:t>
+            </a:r>
+          </a:p>
+        </p:txBody>
+      </p:sp>
+      <p:sp>
+        <p:nvSpPr>
+          <p:cNvPr id="24" name="Rectangle 23"/>
+          <p:cNvSpPr/>
+          <p:nvPr/>
+        </p:nvSpPr>
+        <p:spPr>
+          <a:xfrm>
             <a:off x="360000" y="5562000"/>
             <a:ext cx="10836000" cy="522000"/>
           </a:xfrm>
@@ -5169,42 +5555,46 @@
       </p:sp>
       <p:sp>
         <p:nvSpPr>
-          <p:cNvPr id="22" name="TextBox 21"/>
-          <p:cNvSpPr txBox="1"/>
-          <p:nvPr/>
-        </p:nvSpPr>
-        <p:spPr>
-          <a:xfrm>
-            <a:off x="558000" y="5720400"/>
-            <a:ext cx="10440000" cy="187200"/>
-          </a:xfrm>
-          <a:prstGeom prst="rect">
-            <a:avLst/>
-          </a:prstGeom>
-          <a:noFill/>
-        </p:spPr>
-        <p:txBody>
-          <a:bodyPr wrap="square" lIns="0" tIns="0" rIns="0" bIns="0" anchor="t">
-            <a:spAutoFit/>
-          </a:bodyPr>
-          <a:lstStyle/>
-          <a:p>
-            <a:pPr algn="l"/>
-            <a:r>
-              <a:rPr sz="1220" b="1">
+          <p:cNvPr id="25" name="TextBox 24"/>
+          <p:cNvSpPr txBox="1"/>
+          <p:nvPr/>
+        </p:nvSpPr>
+        <p:spPr>
+          <a:xfrm>
+            <a:off x="558000" y="5688000"/>
+            <a:ext cx="10440000" cy="244800"/>
+          </a:xfrm>
+          <a:prstGeom prst="rect">
+            <a:avLst/>
+          </a:prstGeom>
+          <a:noFill/>
+        </p:spPr>
+        <p:txBody>
+          <a:bodyPr wrap="square" lIns="0" tIns="0" rIns="0" bIns="0" anchor="t">
+            <a:spAutoFit/>
+          </a:bodyPr>
+          <a:lstStyle/>
+          <a:p>
+            <a:pPr algn="l">
+              <a:lnSpc>
+                <a:spcPct val="100000"/>
+              </a:lnSpc>
+            </a:pPr>
+            <a:r>
+              <a:rPr sz="1110" b="1">
                 <a:solidFill>
                   <a:srgbClr val="FFFFFF"/>
                 </a:solidFill>
                 <a:latin typeface="Microsoft YaHei"/>
               </a:rPr>
-              <a:t>总结：本项目把真实天光数据、机器学习光谱估计和室内照明补偿连成了一条可复现的课程设计流程。</a:t>
-            </a:r>
-          </a:p>
-        </p:txBody>
-      </p:sp>
-      <p:sp>
-        <p:nvSpPr>
-          <p:cNvPr id="23" name="TextBox 22"/>
+              <a:t>总结：本项目把真实天光数据、机器学习光谱估计和室内照明补偿连成了一条可复现的课程设计流程；它是课程层面的算法原型，不夸大为硬件成品。</a:t>
+            </a:r>
+          </a:p>
+        </p:txBody>
+      </p:sp>
+      <p:sp>
+        <p:nvSpPr>
+          <p:cNvPr id="26" name="TextBox 25"/>
           <p:cNvSpPr txBox="1"/>
           <p:nvPr/>
         </p:nvSpPr>
@@ -5239,7 +5629,7 @@
       </p:sp>
       <p:sp>
         <p:nvSpPr>
-          <p:cNvPr id="24" name="TextBox 23"/>
+          <p:cNvPr id="27" name="TextBox 26"/>
           <p:cNvSpPr txBox="1"/>
           <p:nvPr/>
         </p:nvSpPr>
@@ -5463,7 +5853,7 @@
         <p:spPr>
           <a:xfrm>
             <a:off x="500400" y="936000"/>
-            <a:ext cx="3765600" cy="378000"/>
+            <a:ext cx="3765600" cy="302400"/>
           </a:xfrm>
           <a:prstGeom prst="rect">
             <a:avLst/>
@@ -5482,7 +5872,7 @@
               </a:lnSpc>
             </a:pPr>
             <a:r>
-              <a:rPr sz="1140" b="0">
+              <a:rPr sz="1080" b="0">
                 <a:solidFill>
                   <a:srgbClr val="0A0A0A"/>
                 </a:solidFill>
@@ -5501,7 +5891,7 @@
         </p:nvSpPr>
         <p:spPr>
           <a:xfrm>
-            <a:off x="378000" y="1371600"/>
+            <a:off x="378000" y="1296000"/>
             <a:ext cx="46800" cy="46800"/>
           </a:xfrm>
           <a:prstGeom prst="rect">
@@ -5544,8 +5934,8 @@
         </p:nvSpPr>
         <p:spPr>
           <a:xfrm>
-            <a:off x="500400" y="1314000"/>
-            <a:ext cx="3765600" cy="378000"/>
+            <a:off x="500400" y="1238400"/>
+            <a:ext cx="3765600" cy="302400"/>
           </a:xfrm>
           <a:prstGeom prst="rect">
             <a:avLst/>
@@ -5564,7 +5954,7 @@
               </a:lnSpc>
             </a:pPr>
             <a:r>
-              <a:rPr sz="1140" b="0">
+              <a:rPr sz="1080" b="0">
                 <a:solidFill>
                   <a:srgbClr val="0A0A0A"/>
                 </a:solidFill>
@@ -5583,7 +5973,7 @@
         </p:nvSpPr>
         <p:spPr>
           <a:xfrm>
-            <a:off x="378000" y="1749600"/>
+            <a:off x="378000" y="1598400"/>
             <a:ext cx="46800" cy="46800"/>
           </a:xfrm>
           <a:prstGeom prst="rect">
@@ -5626,8 +6016,8 @@
         </p:nvSpPr>
         <p:spPr>
           <a:xfrm>
-            <a:off x="500400" y="1692000"/>
-            <a:ext cx="3765600" cy="378000"/>
+            <a:off x="500400" y="1540800"/>
+            <a:ext cx="3765600" cy="302400"/>
           </a:xfrm>
           <a:prstGeom prst="rect">
             <a:avLst/>
@@ -5646,13 +6036,13 @@
               </a:lnSpc>
             </a:pPr>
             <a:r>
-              <a:rPr sz="1140" b="0">
+              <a:rPr sz="1080" b="0">
                 <a:solidFill>
                   <a:srgbClr val="0A0A0A"/>
                 </a:solidFill>
                 <a:latin typeface="Microsoft YaHei"/>
               </a:rPr>
-              <a:t>同亮度、同色温下，光谱形状仍可能明显不同。</a:t>
+              <a:t>光谱表示各波长能量分布，更接近光照质量本身。</a:t>
             </a:r>
           </a:p>
         </p:txBody>
@@ -5665,8 +6055,8 @@
         </p:nvSpPr>
         <p:spPr>
           <a:xfrm>
-            <a:off x="378000" y="2275200"/>
-            <a:ext cx="3834000" cy="774000"/>
+            <a:off x="378000" y="1900800"/>
+            <a:ext cx="46800" cy="46800"/>
           </a:xfrm>
           <a:prstGeom prst="rect">
             <a:avLst/>
@@ -5708,8 +6098,90 @@
         </p:nvSpPr>
         <p:spPr>
           <a:xfrm>
-            <a:off x="522000" y="2404800"/>
-            <a:ext cx="3474000" cy="378000"/>
+            <a:off x="500400" y="1843200"/>
+            <a:ext cx="3765600" cy="302400"/>
+          </a:xfrm>
+          <a:prstGeom prst="rect">
+            <a:avLst/>
+          </a:prstGeom>
+          <a:noFill/>
+        </p:spPr>
+        <p:txBody>
+          <a:bodyPr wrap="square" lIns="0" tIns="0" rIns="0" bIns="0" anchor="t">
+            <a:spAutoFit/>
+          </a:bodyPr>
+          <a:lstStyle/>
+          <a:p>
+            <a:pPr algn="l">
+              <a:lnSpc>
+                <a:spcPct val="107000"/>
+              </a:lnSpc>
+            </a:pPr>
+            <a:r>
+              <a:rPr sz="1080" b="0">
+                <a:solidFill>
+                  <a:srgbClr val="0A0A0A"/>
+                </a:solidFill>
+                <a:latin typeface="Microsoft YaHei"/>
+              </a:rPr>
+              <a:t>同亮度、同色温下，光谱形状仍可能明显不同。</a:t>
+            </a:r>
+          </a:p>
+        </p:txBody>
+      </p:sp>
+      <p:sp>
+        <p:nvSpPr>
+          <p:cNvPr id="13" name="Rectangle 12"/>
+          <p:cNvSpPr/>
+          <p:nvPr/>
+        </p:nvSpPr>
+        <p:spPr>
+          <a:xfrm>
+            <a:off x="378000" y="2224800"/>
+            <a:ext cx="3834000" cy="882000"/>
+          </a:xfrm>
+          <a:prstGeom prst="rect">
+            <a:avLst/>
+          </a:prstGeom>
+          <a:solidFill>
+            <a:srgbClr val="002FA7"/>
+          </a:solidFill>
+          <a:ln>
+            <a:noFill/>
+          </a:ln>
+        </p:spPr>
+        <p:style>
+          <a:lnRef idx="1">
+            <a:schemeClr val="accent1"/>
+          </a:lnRef>
+          <a:fillRef idx="3">
+            <a:schemeClr val="accent1"/>
+          </a:fillRef>
+          <a:effectRef idx="2">
+            <a:schemeClr val="accent1"/>
+          </a:effectRef>
+          <a:fontRef idx="minor">
+            <a:schemeClr val="lt1"/>
+          </a:fontRef>
+        </p:style>
+        <p:txBody>
+          <a:bodyPr rtlCol="0" anchor="ctr"/>
+          <a:lstStyle/>
+          <a:p>
+            <a:pPr algn="ctr"/>
+          </a:p>
+        </p:txBody>
+      </p:sp>
+      <p:sp>
+        <p:nvSpPr>
+          <p:cNvPr id="14" name="TextBox 13"/>
+          <p:cNvSpPr txBox="1"/>
+          <p:nvPr/>
+        </p:nvSpPr>
+        <p:spPr>
+          <a:xfrm>
+            <a:off x="522000" y="2340000"/>
+            <a:ext cx="3474000" cy="558000"/>
           </a:xfrm>
           <a:prstGeom prst="rect">
             <a:avLst/>
@@ -5728,13 +6200,13 @@
               </a:lnSpc>
             </a:pPr>
             <a:r>
-              <a:rPr sz="1300" b="1">
+              <a:rPr sz="1140" b="1">
                 <a:solidFill>
                   <a:srgbClr val="FFFFFF"/>
                 </a:solidFill>
                 <a:latin typeface="Microsoft YaHei"/>
               </a:rPr>
-              <a:t>因此，本项目从“光谱”角度描述自然光，</a:t>
+              <a:t>读图方式：不同天气曲线不完全重合，</a:t>
             </a:r>
           </a:p>
           <a:p>
@@ -5744,20 +6216,270 @@
               </a:lnSpc>
             </a:pPr>
             <a:r>
-              <a:rPr sz="1300" b="1">
+              <a:rPr sz="1140" b="1">
                 <a:solidFill>
                   <a:srgbClr val="FFFFFF"/>
                 </a:solidFill>
                 <a:latin typeface="Microsoft YaHei"/>
               </a:rPr>
-              <a:t>并把估计结果用于室内补偿。</a:t>
+              <a:t>说明自然光光谱会随环境变化。</a:t>
+            </a:r>
+          </a:p>
+          <a:p>
+            <a:pPr algn="l">
+              <a:lnSpc>
+                <a:spcPct val="100000"/>
+              </a:lnSpc>
+            </a:pPr>
+            <a:r>
+              <a:rPr sz="1140" b="1">
+                <a:solidFill>
+                  <a:srgbClr val="FFFFFF"/>
+                </a:solidFill>
+                <a:latin typeface="Microsoft YaHei"/>
+              </a:rPr>
+              <a:t>因此要用“光谱”而不只用亮度/色温描述。</a:t>
+            </a:r>
+          </a:p>
+        </p:txBody>
+      </p:sp>
+      <p:sp>
+        <p:nvSpPr>
+          <p:cNvPr id="15" name="Rectangle 14"/>
+          <p:cNvSpPr/>
+          <p:nvPr/>
+        </p:nvSpPr>
+        <p:spPr>
+          <a:xfrm>
+            <a:off x="378000" y="3304800"/>
+            <a:ext cx="3834000" cy="1116000"/>
+          </a:xfrm>
+          <a:prstGeom prst="rect">
+            <a:avLst/>
+          </a:prstGeom>
+          <a:solidFill>
+            <a:srgbClr val="F0F0EE"/>
+          </a:solidFill>
+          <a:ln>
+            <a:noFill/>
+          </a:ln>
+        </p:spPr>
+        <p:style>
+          <a:lnRef idx="1">
+            <a:schemeClr val="accent1"/>
+          </a:lnRef>
+          <a:fillRef idx="3">
+            <a:schemeClr val="accent1"/>
+          </a:fillRef>
+          <a:effectRef idx="2">
+            <a:schemeClr val="accent1"/>
+          </a:effectRef>
+          <a:fontRef idx="minor">
+            <a:schemeClr val="lt1"/>
+          </a:fontRef>
+        </p:style>
+        <p:txBody>
+          <a:bodyPr rtlCol="0" anchor="ctr"/>
+          <a:lstStyle/>
+          <a:p>
+            <a:pPr algn="ctr"/>
+          </a:p>
+        </p:txBody>
+      </p:sp>
+      <p:sp>
+        <p:nvSpPr>
+          <p:cNvPr id="16" name="TextBox 15"/>
+          <p:cNvSpPr txBox="1"/>
+          <p:nvPr/>
+        </p:nvSpPr>
+        <p:spPr>
+          <a:xfrm>
+            <a:off x="503999" y="3394800"/>
+            <a:ext cx="3582000" cy="122400"/>
+          </a:xfrm>
+          <a:prstGeom prst="rect">
+            <a:avLst/>
+          </a:prstGeom>
+          <a:noFill/>
+        </p:spPr>
+        <p:txBody>
+          <a:bodyPr wrap="square" lIns="0" tIns="0" rIns="0" bIns="0" anchor="t">
+            <a:spAutoFit/>
+          </a:bodyPr>
+          <a:lstStyle/>
+          <a:p>
+            <a:pPr algn="l"/>
+            <a:r>
+              <a:rPr sz="940" b="1">
+                <a:solidFill>
+                  <a:srgbClr val="002FA7"/>
+                </a:solidFill>
+                <a:latin typeface="Microsoft YaHei"/>
+              </a:rPr>
+              <a:t>研究切入点</a:t>
+            </a:r>
+          </a:p>
+        </p:txBody>
+      </p:sp>
+      <p:sp>
+        <p:nvSpPr>
+          <p:cNvPr id="17" name="TextBox 16"/>
+          <p:cNvSpPr txBox="1"/>
+          <p:nvPr/>
+        </p:nvSpPr>
+        <p:spPr>
+          <a:xfrm>
+            <a:off x="503999" y="3585599"/>
+            <a:ext cx="3582000" cy="784800"/>
+          </a:xfrm>
+          <a:prstGeom prst="rect">
+            <a:avLst/>
+          </a:prstGeom>
+          <a:noFill/>
+        </p:spPr>
+        <p:txBody>
+          <a:bodyPr wrap="square" lIns="0" tIns="0" rIns="0" bIns="0" anchor="t">
+            <a:spAutoFit/>
+          </a:bodyPr>
+          <a:lstStyle/>
+          <a:p>
+            <a:pPr algn="l">
+              <a:lnSpc>
+                <a:spcPct val="103000"/>
+              </a:lnSpc>
+            </a:pPr>
+            <a:r>
+              <a:rPr sz="869" b="0">
+                <a:solidFill>
+                  <a:srgbClr val="0A0A0A"/>
+                </a:solidFill>
+                <a:latin typeface="Microsoft YaHei"/>
+              </a:rPr>
+              <a:t>研究从室内照明场景出发：人长期处于室内，照明质量会影响学习、办公和视觉舒适。亮度和色温虽然直观，但无法说明每个波长的能量分布。</a:t>
+            </a:r>
+          </a:p>
+        </p:txBody>
+      </p:sp>
+      <p:sp>
+        <p:nvSpPr>
+          <p:cNvPr id="18" name="Rectangle 17"/>
+          <p:cNvSpPr/>
+          <p:nvPr/>
+        </p:nvSpPr>
+        <p:spPr>
+          <a:xfrm>
+            <a:off x="378000" y="4543200"/>
+            <a:ext cx="3834000" cy="810000"/>
+          </a:xfrm>
+          <a:prstGeom prst="rect">
+            <a:avLst/>
+          </a:prstGeom>
+          <a:solidFill>
+            <a:srgbClr val="FAFAF8"/>
+          </a:solidFill>
+          <a:ln>
+            <a:noFill/>
+          </a:ln>
+        </p:spPr>
+        <p:style>
+          <a:lnRef idx="1">
+            <a:schemeClr val="accent1"/>
+          </a:lnRef>
+          <a:fillRef idx="3">
+            <a:schemeClr val="accent1"/>
+          </a:fillRef>
+          <a:effectRef idx="2">
+            <a:schemeClr val="accent1"/>
+          </a:effectRef>
+          <a:fontRef idx="minor">
+            <a:schemeClr val="lt1"/>
+          </a:fontRef>
+        </p:style>
+        <p:txBody>
+          <a:bodyPr rtlCol="0" anchor="ctr"/>
+          <a:lstStyle/>
+          <a:p>
+            <a:pPr algn="ctr"/>
+          </a:p>
+        </p:txBody>
+      </p:sp>
+      <p:sp>
+        <p:nvSpPr>
+          <p:cNvPr id="19" name="TextBox 18"/>
+          <p:cNvSpPr txBox="1"/>
+          <p:nvPr/>
+        </p:nvSpPr>
+        <p:spPr>
+          <a:xfrm>
+            <a:off x="503999" y="4633200"/>
+            <a:ext cx="3582000" cy="122400"/>
+          </a:xfrm>
+          <a:prstGeom prst="rect">
+            <a:avLst/>
+          </a:prstGeom>
+          <a:noFill/>
+        </p:spPr>
+        <p:txBody>
+          <a:bodyPr wrap="square" lIns="0" tIns="0" rIns="0" bIns="0" anchor="t">
+            <a:spAutoFit/>
+          </a:bodyPr>
+          <a:lstStyle/>
+          <a:p>
+            <a:pPr algn="l"/>
+            <a:r>
+              <a:rPr sz="940" b="1">
+                <a:solidFill>
+                  <a:srgbClr val="002FA7"/>
+                </a:solidFill>
+                <a:latin typeface="Microsoft YaHei"/>
+              </a:rPr>
+              <a:t>建模问题</a:t>
+            </a:r>
+          </a:p>
+        </p:txBody>
+      </p:sp>
+      <p:sp>
+        <p:nvSpPr>
+          <p:cNvPr id="20" name="TextBox 19"/>
+          <p:cNvSpPr txBox="1"/>
+          <p:nvPr/>
+        </p:nvSpPr>
+        <p:spPr>
+          <a:xfrm>
+            <a:off x="503999" y="4823999"/>
+            <a:ext cx="3582000" cy="478800"/>
+          </a:xfrm>
+          <a:prstGeom prst="rect">
+            <a:avLst/>
+          </a:prstGeom>
+          <a:noFill/>
+        </p:spPr>
+        <p:txBody>
+          <a:bodyPr wrap="square" lIns="0" tIns="0" rIns="0" bIns="0" anchor="t">
+            <a:spAutoFit/>
+          </a:bodyPr>
+          <a:lstStyle/>
+          <a:p>
+            <a:pPr algn="l">
+              <a:lnSpc>
+                <a:spcPct val="103000"/>
+              </a:lnSpc>
+            </a:pPr>
+            <a:r>
+              <a:rPr sz="869" b="0">
+                <a:solidFill>
+                  <a:srgbClr val="0A0A0A"/>
+                </a:solidFill>
+                <a:latin typeface="Microsoft YaHei"/>
+              </a:rPr>
+              <a:t>天气变化会改变自然光光谱形状，因此可以进一步尝试利用天气、时间和太阳位置等环境特征去估计这条光谱曲线。</a:t>
             </a:r>
           </a:p>
         </p:txBody>
       </p:sp>
       <p:pic>
         <p:nvPicPr>
-          <p:cNvPr id="13" name="Picture 12" descr="weather_spectrum_compare.png"/>
+          <p:cNvPr id="21" name="Picture 20" descr="weather_spectrum_compare.png"/>
           <p:cNvPicPr>
             <a:picLocks noChangeAspect="1"/>
           </p:cNvPicPr>
@@ -5781,7 +6503,7 @@
       </p:pic>
       <p:sp>
         <p:nvSpPr>
-          <p:cNvPr id="14" name="TextBox 13"/>
+          <p:cNvPr id="22" name="TextBox 21"/>
           <p:cNvSpPr txBox="1"/>
           <p:nvPr/>
         </p:nvSpPr>
@@ -5816,7 +6538,7 @@
       </p:sp>
       <p:sp>
         <p:nvSpPr>
-          <p:cNvPr id="15" name="TextBox 14"/>
+          <p:cNvPr id="23" name="TextBox 22"/>
           <p:cNvSpPr txBox="1"/>
           <p:nvPr/>
         </p:nvSpPr>
@@ -5851,7 +6573,7 @@
       </p:sp>
       <p:sp>
         <p:nvSpPr>
-          <p:cNvPr id="16" name="TextBox 15"/>
+          <p:cNvPr id="24" name="TextBox 23"/>
           <p:cNvSpPr txBox="1"/>
           <p:nvPr/>
         </p:nvSpPr>
@@ -6135,7 +6857,7 @@
                 </a:solidFill>
                 <a:latin typeface="Microsoft YaHei"/>
               </a:rPr>
-              <a:t>天气类别、云量、湿度、温度、降水</a:t>
+              <a:t>不直接依赖光谱仪</a:t>
             </a:r>
           </a:p>
           <a:p>
@@ -6151,7 +6873,7 @@
                 </a:solidFill>
                 <a:latin typeface="Microsoft YaHei"/>
               </a:rPr>
-              <a:t>时间、月份、地点</a:t>
+              <a:t>天气类别、云量、湿度、温度、降水</a:t>
             </a:r>
           </a:p>
           <a:p>
@@ -6167,7 +6889,7 @@
                 </a:solidFill>
                 <a:latin typeface="Microsoft YaHei"/>
               </a:rPr>
-              <a:t>太阳高度角/方位角</a:t>
+              <a:t>时间、月份、地点</a:t>
             </a:r>
           </a:p>
           <a:p>
@@ -6183,7 +6905,7 @@
                 </a:solidFill>
                 <a:latin typeface="Microsoft YaHei"/>
               </a:rPr>
-              <a:t>室外水平照度</a:t>
+              <a:t>太阳高度角/方位角、室外照度</a:t>
             </a:r>
           </a:p>
         </p:txBody>
@@ -6300,7 +7022,7 @@
                 </a:solidFill>
                 <a:latin typeface="Microsoft YaHei"/>
               </a:rPr>
-              <a:t>380–780 nm</a:t>
+              <a:t>380–780 nm 可见光范围</a:t>
             </a:r>
           </a:p>
           <a:p>
@@ -6316,7 +7038,7 @@
                 </a:solidFill>
                 <a:latin typeface="Microsoft YaHei"/>
               </a:rPr>
-              <a:t>每 10 nm 一个点</a:t>
+              <a:t>每 10 nm 一个点，共 41 维</a:t>
             </a:r>
           </a:p>
           <a:p>
@@ -6332,7 +7054,7 @@
                 </a:solidFill>
                 <a:latin typeface="Microsoft YaHei"/>
               </a:rPr>
-              <a:t>共 41 维相对光谱曲线</a:t>
+              <a:t>关注相对光谱形状</a:t>
             </a:r>
           </a:p>
           <a:p>
@@ -6348,7 +7070,7 @@
                 </a:solidFill>
                 <a:latin typeface="Microsoft YaHei"/>
               </a:rPr>
-              <a:t>模型先预测 PCA 系数，再还原光谱</a:t>
+              <a:t>先预测 PCA 系数，再还原曲线</a:t>
             </a:r>
           </a:p>
         </p:txBody>
@@ -6465,7 +7187,7 @@
                 </a:solidFill>
                 <a:latin typeface="Microsoft YaHei"/>
               </a:rPr>
-              <a:t>根据目标自然光谱与当前自然光贡献</a:t>
+              <a:t>计算“目标光谱 - 当前自然光”</a:t>
             </a:r>
           </a:p>
           <a:p>
@@ -6481,7 +7203,7 @@
                 </a:solidFill>
                 <a:latin typeface="Microsoft YaHei"/>
               </a:rPr>
-              <a:t>计算七通道 LED 推荐比例</a:t>
+              <a:t>输出七通道 LED 推荐比例</a:t>
             </a:r>
           </a:p>
           <a:p>
@@ -6497,7 +7219,23 @@
                 </a:solidFill>
                 <a:latin typeface="Microsoft YaHei"/>
               </a:rPr>
-              <a:t>形成“预测 → 补偿 → 对比”的闭环</a:t>
+              <a:t>对比多通道与传统双色温</a:t>
+            </a:r>
+          </a:p>
+          <a:p>
+            <a:pPr algn="l">
+              <a:lnSpc>
+                <a:spcPct val="105000"/>
+              </a:lnSpc>
+            </a:pPr>
+            <a:r>
+              <a:rPr sz="960" b="0">
+                <a:solidFill>
+                  <a:srgbClr val="0A0A0A"/>
+                </a:solidFill>
+                <a:latin typeface="Microsoft YaHei"/>
+              </a:rPr>
+              <a:t>形成预测、补偿、评价闭环</a:t>
             </a:r>
           </a:p>
         </p:txBody>
@@ -6580,6 +7318,123 @@
         </p:nvSpPr>
         <p:spPr>
           <a:xfrm>
+            <a:off x="1332000" y="3258000"/>
+            <a:ext cx="8856000" cy="450000"/>
+          </a:xfrm>
+          <a:prstGeom prst="rect">
+            <a:avLst/>
+          </a:prstGeom>
+          <a:solidFill>
+            <a:srgbClr val="F0F0EE"/>
+          </a:solidFill>
+          <a:ln>
+            <a:noFill/>
+          </a:ln>
+        </p:spPr>
+        <p:style>
+          <a:lnRef idx="1">
+            <a:schemeClr val="accent1"/>
+          </a:lnRef>
+          <a:fillRef idx="3">
+            <a:schemeClr val="accent1"/>
+          </a:fillRef>
+          <a:effectRef idx="2">
+            <a:schemeClr val="accent1"/>
+          </a:effectRef>
+          <a:fontRef idx="minor">
+            <a:schemeClr val="lt1"/>
+          </a:fontRef>
+        </p:style>
+        <p:txBody>
+          <a:bodyPr rtlCol="0" anchor="ctr"/>
+          <a:lstStyle/>
+          <a:p>
+            <a:pPr algn="ctr"/>
+          </a:p>
+        </p:txBody>
+      </p:sp>
+      <p:sp>
+        <p:nvSpPr>
+          <p:cNvPr id="17" name="TextBox 16"/>
+          <p:cNvSpPr txBox="1"/>
+          <p:nvPr/>
+        </p:nvSpPr>
+        <p:spPr>
+          <a:xfrm>
+            <a:off x="1458000" y="3348000"/>
+            <a:ext cx="8604000" cy="122400"/>
+          </a:xfrm>
+          <a:prstGeom prst="rect">
+            <a:avLst/>
+          </a:prstGeom>
+          <a:noFill/>
+        </p:spPr>
+        <p:txBody>
+          <a:bodyPr wrap="square" lIns="0" tIns="0" rIns="0" bIns="0" anchor="t">
+            <a:spAutoFit/>
+          </a:bodyPr>
+          <a:lstStyle/>
+          <a:p>
+            <a:pPr algn="l"/>
+            <a:r>
+              <a:rPr sz="940" b="1">
+                <a:solidFill>
+                  <a:srgbClr val="002FA7"/>
+                </a:solidFill>
+                <a:latin typeface="Microsoft YaHei"/>
+              </a:rPr>
+              <a:t>设计思路</a:t>
+            </a:r>
+          </a:p>
+        </p:txBody>
+      </p:sp>
+      <p:sp>
+        <p:nvSpPr>
+          <p:cNvPr id="18" name="TextBox 17"/>
+          <p:cNvSpPr txBox="1"/>
+          <p:nvPr/>
+        </p:nvSpPr>
+        <p:spPr>
+          <a:xfrm>
+            <a:off x="1458000" y="3538800"/>
+            <a:ext cx="8604000" cy="118799"/>
+          </a:xfrm>
+          <a:prstGeom prst="rect">
+            <a:avLst/>
+          </a:prstGeom>
+          <a:noFill/>
+        </p:spPr>
+        <p:txBody>
+          <a:bodyPr wrap="square" lIns="0" tIns="0" rIns="0" bIns="0" anchor="t">
+            <a:spAutoFit/>
+          </a:bodyPr>
+          <a:lstStyle/>
+          <a:p>
+            <a:pPr algn="l">
+              <a:lnSpc>
+                <a:spcPct val="103000"/>
+              </a:lnSpc>
+            </a:pPr>
+            <a:r>
+              <a:rPr sz="869" b="0">
+                <a:solidFill>
+                  <a:srgbClr val="0A0A0A"/>
+                </a:solidFill>
+                <a:latin typeface="Microsoft YaHei"/>
+              </a:rPr>
+              <a:t>输入端尽量选择低成本、容易获得的环境特征；输出端不直接给一个色温值，而是还原完整相对光谱。这样预测结果才能继续用于光谱级补偿。</a:t>
+            </a:r>
+          </a:p>
+        </p:txBody>
+      </p:sp>
+      <p:sp>
+        <p:nvSpPr>
+          <p:cNvPr id="19" name="Rectangle 18"/>
+          <p:cNvSpPr/>
+          <p:nvPr/>
+        </p:nvSpPr>
+        <p:spPr>
+          <a:xfrm>
             <a:off x="1332000" y="3888000"/>
             <a:ext cx="8856000" cy="1134000"/>
           </a:xfrm>
@@ -6619,7 +7474,7 @@
       </p:sp>
       <p:sp>
         <p:nvSpPr>
-          <p:cNvPr id="17" name="Rectangle 16"/>
+          <p:cNvPr id="20" name="Rectangle 19"/>
           <p:cNvSpPr/>
           <p:nvPr/>
         </p:nvSpPr>
@@ -6662,7 +7517,7 @@
       </p:sp>
       <p:sp>
         <p:nvSpPr>
-          <p:cNvPr id="18" name="TextBox 17"/>
+          <p:cNvPr id="21" name="TextBox 20"/>
           <p:cNvSpPr txBox="1"/>
           <p:nvPr/>
         </p:nvSpPr>
@@ -6697,7 +7552,7 @@
       </p:sp>
       <p:cxnSp>
         <p:nvCxnSpPr>
-          <p:cNvPr id="19" name="Connector 18"/>
+          <p:cNvPr id="22" name="Connector 21"/>
           <p:cNvCxnSpPr/>
           <p:nvPr/>
         </p:nvCxnSpPr>
@@ -6732,7 +7587,7 @@
       </p:cxnSp>
       <p:sp>
         <p:nvSpPr>
-          <p:cNvPr id="20" name="Rectangle 19"/>
+          <p:cNvPr id="23" name="Rectangle 22"/>
           <p:cNvSpPr/>
           <p:nvPr/>
         </p:nvSpPr>
@@ -6775,7 +7630,7 @@
       </p:sp>
       <p:sp>
         <p:nvSpPr>
-          <p:cNvPr id="21" name="TextBox 20"/>
+          <p:cNvPr id="24" name="TextBox 23"/>
           <p:cNvSpPr txBox="1"/>
           <p:nvPr/>
         </p:nvSpPr>
@@ -6810,7 +7665,7 @@
       </p:sp>
       <p:cxnSp>
         <p:nvCxnSpPr>
-          <p:cNvPr id="22" name="Connector 21"/>
+          <p:cNvPr id="25" name="Connector 24"/>
           <p:cNvCxnSpPr/>
           <p:nvPr/>
         </p:nvCxnSpPr>
@@ -6845,7 +7700,7 @@
       </p:cxnSp>
       <p:sp>
         <p:nvSpPr>
-          <p:cNvPr id="23" name="Rectangle 22"/>
+          <p:cNvPr id="26" name="Rectangle 25"/>
           <p:cNvSpPr/>
           <p:nvPr/>
         </p:nvSpPr>
@@ -6888,7 +7743,7 @@
       </p:sp>
       <p:sp>
         <p:nvSpPr>
-          <p:cNvPr id="24" name="TextBox 23"/>
+          <p:cNvPr id="27" name="TextBox 26"/>
           <p:cNvSpPr txBox="1"/>
           <p:nvPr/>
         </p:nvSpPr>
@@ -6923,7 +7778,7 @@
       </p:sp>
       <p:cxnSp>
         <p:nvCxnSpPr>
-          <p:cNvPr id="25" name="Connector 24"/>
+          <p:cNvPr id="28" name="Connector 27"/>
           <p:cNvCxnSpPr/>
           <p:nvPr/>
         </p:nvCxnSpPr>
@@ -6958,7 +7813,7 @@
       </p:cxnSp>
       <p:sp>
         <p:nvSpPr>
-          <p:cNvPr id="26" name="Rectangle 25"/>
+          <p:cNvPr id="29" name="Rectangle 28"/>
           <p:cNvSpPr/>
           <p:nvPr/>
         </p:nvSpPr>
@@ -7001,7 +7856,7 @@
       </p:sp>
       <p:sp>
         <p:nvSpPr>
-          <p:cNvPr id="27" name="TextBox 26"/>
+          <p:cNvPr id="30" name="TextBox 29"/>
           <p:cNvSpPr txBox="1"/>
           <p:nvPr/>
         </p:nvSpPr>
@@ -7036,7 +7891,7 @@
       </p:sp>
       <p:cxnSp>
         <p:nvCxnSpPr>
-          <p:cNvPr id="28" name="Connector 27"/>
+          <p:cNvPr id="31" name="Connector 30"/>
           <p:cNvCxnSpPr/>
           <p:nvPr/>
         </p:nvCxnSpPr>
@@ -7071,7 +7926,7 @@
       </p:cxnSp>
       <p:sp>
         <p:nvSpPr>
-          <p:cNvPr id="29" name="Rectangle 28"/>
+          <p:cNvPr id="32" name="Rectangle 31"/>
           <p:cNvSpPr/>
           <p:nvPr/>
         </p:nvSpPr>
@@ -7114,7 +7969,7 @@
       </p:sp>
       <p:sp>
         <p:nvSpPr>
-          <p:cNvPr id="30" name="TextBox 29"/>
+          <p:cNvPr id="33" name="TextBox 32"/>
           <p:cNvSpPr txBox="1"/>
           <p:nvPr/>
         </p:nvSpPr>
@@ -7149,7 +8004,89 @@
       </p:sp>
       <p:sp>
         <p:nvSpPr>
-          <p:cNvPr id="31" name="TextBox 30"/>
+          <p:cNvPr id="34" name="Rectangle 33"/>
+          <p:cNvSpPr/>
+          <p:nvPr/>
+        </p:nvSpPr>
+        <p:spPr>
+          <a:xfrm>
+            <a:off x="1332000" y="5202000"/>
+            <a:ext cx="8856000" cy="306000"/>
+          </a:xfrm>
+          <a:prstGeom prst="rect">
+            <a:avLst/>
+          </a:prstGeom>
+          <a:solidFill>
+            <a:srgbClr val="002FA7"/>
+          </a:solidFill>
+          <a:ln>
+            <a:noFill/>
+          </a:ln>
+        </p:spPr>
+        <p:style>
+          <a:lnRef idx="1">
+            <a:schemeClr val="accent1"/>
+          </a:lnRef>
+          <a:fillRef idx="3">
+            <a:schemeClr val="accent1"/>
+          </a:fillRef>
+          <a:effectRef idx="2">
+            <a:schemeClr val="accent1"/>
+          </a:effectRef>
+          <a:fontRef idx="minor">
+            <a:schemeClr val="lt1"/>
+          </a:fontRef>
+        </p:style>
+        <p:txBody>
+          <a:bodyPr rtlCol="0" anchor="ctr"/>
+          <a:lstStyle/>
+          <a:p>
+            <a:pPr algn="ctr"/>
+          </a:p>
+        </p:txBody>
+      </p:sp>
+      <p:sp>
+        <p:nvSpPr>
+          <p:cNvPr id="35" name="TextBox 34"/>
+          <p:cNvSpPr txBox="1"/>
+          <p:nvPr/>
+        </p:nvSpPr>
+        <p:spPr>
+          <a:xfrm>
+            <a:off x="1458000" y="5284800"/>
+            <a:ext cx="8604000" cy="183600"/>
+          </a:xfrm>
+          <a:prstGeom prst="rect">
+            <a:avLst/>
+          </a:prstGeom>
+          <a:noFill/>
+        </p:spPr>
+        <p:txBody>
+          <a:bodyPr wrap="square" lIns="0" tIns="0" rIns="0" bIns="0" anchor="t">
+            <a:spAutoFit/>
+          </a:bodyPr>
+          <a:lstStyle/>
+          <a:p>
+            <a:pPr algn="l">
+              <a:lnSpc>
+                <a:spcPct val="100000"/>
+              </a:lnSpc>
+            </a:pPr>
+            <a:r>
+              <a:rPr sz="1019" b="1">
+                <a:solidFill>
+                  <a:srgbClr val="FFFFFF"/>
+                </a:solidFill>
+                <a:latin typeface="Microsoft YaHei"/>
+              </a:rPr>
+              <a:t>一句话目标：用低成本环境特征估计自然光相对光谱，并服务于室内照明补偿。</a:t>
+            </a:r>
+          </a:p>
+        </p:txBody>
+      </p:sp>
+      <p:sp>
+        <p:nvSpPr>
+          <p:cNvPr id="36" name="TextBox 35"/>
           <p:cNvSpPr txBox="1"/>
           <p:nvPr/>
         </p:nvSpPr>
@@ -7184,7 +8121,7 @@
       </p:sp>
       <p:sp>
         <p:nvSpPr>
-          <p:cNvPr id="32" name="TextBox 31"/>
+          <p:cNvPr id="37" name="TextBox 36"/>
           <p:cNvSpPr txBox="1"/>
           <p:nvPr/>
         </p:nvSpPr>
@@ -7811,6 +8748,123 @@
         </p:nvSpPr>
         <p:spPr>
           <a:xfrm>
+            <a:off x="360000" y="2916000"/>
+            <a:ext cx="10818000" cy="388800"/>
+          </a:xfrm>
+          <a:prstGeom prst="rect">
+            <a:avLst/>
+          </a:prstGeom>
+          <a:solidFill>
+            <a:srgbClr val="F0F0EE"/>
+          </a:solidFill>
+          <a:ln>
+            <a:noFill/>
+          </a:ln>
+        </p:spPr>
+        <p:style>
+          <a:lnRef idx="1">
+            <a:schemeClr val="accent1"/>
+          </a:lnRef>
+          <a:fillRef idx="3">
+            <a:schemeClr val="accent1"/>
+          </a:fillRef>
+          <a:effectRef idx="2">
+            <a:schemeClr val="accent1"/>
+          </a:effectRef>
+          <a:fontRef idx="minor">
+            <a:schemeClr val="lt1"/>
+          </a:fontRef>
+        </p:style>
+        <p:txBody>
+          <a:bodyPr rtlCol="0" anchor="ctr"/>
+          <a:lstStyle/>
+          <a:p>
+            <a:pPr algn="ctr"/>
+          </a:p>
+        </p:txBody>
+      </p:sp>
+      <p:sp>
+        <p:nvSpPr>
+          <p:cNvPr id="15" name="TextBox 14"/>
+          <p:cNvSpPr txBox="1"/>
+          <p:nvPr/>
+        </p:nvSpPr>
+        <p:spPr>
+          <a:xfrm>
+            <a:off x="486000" y="3006000"/>
+            <a:ext cx="10566000" cy="122400"/>
+          </a:xfrm>
+          <a:prstGeom prst="rect">
+            <a:avLst/>
+          </a:prstGeom>
+          <a:noFill/>
+        </p:spPr>
+        <p:txBody>
+          <a:bodyPr wrap="square" lIns="0" tIns="0" rIns="0" bIns="0" anchor="t">
+            <a:spAutoFit/>
+          </a:bodyPr>
+          <a:lstStyle/>
+          <a:p>
+            <a:pPr algn="l"/>
+            <a:r>
+              <a:rPr sz="940" b="1">
+                <a:solidFill>
+                  <a:srgbClr val="002FA7"/>
+                </a:solidFill>
+                <a:latin typeface="Microsoft YaHei"/>
+              </a:rPr>
+              <a:t>数据处理后的建模表</a:t>
+            </a:r>
+          </a:p>
+        </p:txBody>
+      </p:sp>
+      <p:sp>
+        <p:nvSpPr>
+          <p:cNvPr id="16" name="TextBox 15"/>
+          <p:cNvSpPr txBox="1"/>
+          <p:nvPr/>
+        </p:nvSpPr>
+        <p:spPr>
+          <a:xfrm>
+            <a:off x="486000" y="3196799"/>
+            <a:ext cx="10566000" cy="57600"/>
+          </a:xfrm>
+          <a:prstGeom prst="rect">
+            <a:avLst/>
+          </a:prstGeom>
+          <a:noFill/>
+        </p:spPr>
+        <p:txBody>
+          <a:bodyPr wrap="square" lIns="0" tIns="0" rIns="0" bIns="0" anchor="t">
+            <a:spAutoFit/>
+          </a:bodyPr>
+          <a:lstStyle/>
+          <a:p>
+            <a:pPr algn="l">
+              <a:lnSpc>
+                <a:spcPct val="103000"/>
+              </a:lnSpc>
+            </a:pPr>
+            <a:r>
+              <a:rPr sz="869" b="0">
+                <a:solidFill>
+                  <a:srgbClr val="0A0A0A"/>
+                </a:solidFill>
+                <a:latin typeface="Microsoft YaHei"/>
+              </a:rPr>
+              <a:t>最终每一行样本都包含：观测时间和地点、天气特征、太阳位置、室外照度，以及 41 个波长点的相对光谱强度。也就是说，模型看到的是“环境条件 → 光谱形状”的配对样本。</a:t>
+            </a:r>
+          </a:p>
+        </p:txBody>
+      </p:sp>
+      <p:sp>
+        <p:nvSpPr>
+          <p:cNvPr id="17" name="Rectangle 16"/>
+          <p:cNvSpPr/>
+          <p:nvPr/>
+        </p:nvSpPr>
+        <p:spPr>
+          <a:xfrm>
             <a:off x="360000" y="3401999"/>
             <a:ext cx="10818000" cy="1548000"/>
           </a:xfrm>
@@ -7850,7 +8904,7 @@
       </p:sp>
       <p:sp>
         <p:nvSpPr>
-          <p:cNvPr id="15" name="TextBox 14"/>
+          <p:cNvPr id="18" name="TextBox 17"/>
           <p:cNvSpPr txBox="1"/>
           <p:nvPr/>
         </p:nvSpPr>
@@ -7885,7 +8939,7 @@
       </p:sp>
       <p:sp>
         <p:nvSpPr>
-          <p:cNvPr id="16" name="TextBox 15"/>
+          <p:cNvPr id="19" name="TextBox 18"/>
           <p:cNvSpPr txBox="1"/>
           <p:nvPr/>
         </p:nvSpPr>
@@ -7920,7 +8974,7 @@
       </p:sp>
       <p:sp>
         <p:nvSpPr>
-          <p:cNvPr id="17" name="TextBox 16"/>
+          <p:cNvPr id="20" name="TextBox 19"/>
           <p:cNvSpPr txBox="1"/>
           <p:nvPr/>
         </p:nvSpPr>
@@ -7955,7 +9009,7 @@
       </p:sp>
       <p:sp>
         <p:nvSpPr>
-          <p:cNvPr id="18" name="TextBox 17"/>
+          <p:cNvPr id="21" name="TextBox 20"/>
           <p:cNvSpPr txBox="1"/>
           <p:nvPr/>
         </p:nvSpPr>
@@ -7990,7 +9044,7 @@
       </p:sp>
       <p:sp>
         <p:nvSpPr>
-          <p:cNvPr id="19" name="TextBox 18"/>
+          <p:cNvPr id="22" name="TextBox 21"/>
           <p:cNvSpPr txBox="1"/>
           <p:nvPr/>
         </p:nvSpPr>
@@ -8025,7 +9079,7 @@
       </p:sp>
       <p:sp>
         <p:nvSpPr>
-          <p:cNvPr id="20" name="TextBox 19"/>
+          <p:cNvPr id="23" name="TextBox 22"/>
           <p:cNvSpPr txBox="1"/>
           <p:nvPr/>
         </p:nvSpPr>
@@ -8060,7 +9114,7 @@
       </p:sp>
       <p:sp>
         <p:nvSpPr>
-          <p:cNvPr id="21" name="TextBox 20"/>
+          <p:cNvPr id="24" name="TextBox 23"/>
           <p:cNvSpPr txBox="1"/>
           <p:nvPr/>
         </p:nvSpPr>
@@ -8095,7 +9149,7 @@
       </p:sp>
       <p:sp>
         <p:nvSpPr>
-          <p:cNvPr id="22" name="TextBox 21"/>
+          <p:cNvPr id="25" name="TextBox 24"/>
           <p:cNvSpPr txBox="1"/>
           <p:nvPr/>
         </p:nvSpPr>
@@ -8130,7 +9184,7 @@
       </p:sp>
       <p:sp>
         <p:nvSpPr>
-          <p:cNvPr id="23" name="TextBox 22"/>
+          <p:cNvPr id="26" name="TextBox 25"/>
           <p:cNvSpPr txBox="1"/>
           <p:nvPr/>
         </p:nvSpPr>
@@ -8165,7 +9219,7 @@
       </p:sp>
       <p:sp>
         <p:nvSpPr>
-          <p:cNvPr id="24" name="TextBox 23"/>
+          <p:cNvPr id="27" name="TextBox 26"/>
           <p:cNvSpPr txBox="1"/>
           <p:nvPr/>
         </p:nvSpPr>
@@ -8200,13 +9254,13 @@
       </p:sp>
       <p:sp>
         <p:nvSpPr>
-          <p:cNvPr id="25" name="TextBox 24"/>
-          <p:cNvSpPr txBox="1"/>
-          <p:nvPr/>
-        </p:nvSpPr>
-        <p:spPr>
-          <a:xfrm>
-            <a:off x="737999" y="4723200"/>
+          <p:cNvPr id="28" name="TextBox 27"/>
+          <p:cNvSpPr txBox="1"/>
+          <p:nvPr/>
+        </p:nvSpPr>
+        <p:spPr>
+          <a:xfrm>
+            <a:off x="737999" y="4615200"/>
             <a:ext cx="9792000" cy="162000"/>
           </a:xfrm>
           <a:prstGeom prst="rect">
@@ -8222,20 +9276,55 @@
           <a:p>
             <a:pPr algn="l"/>
             <a:r>
+              <a:rPr sz="930" b="1">
+                <a:solidFill>
+                  <a:srgbClr val="0A0A0A"/>
+                </a:solidFill>
+                <a:latin typeface="Microsoft YaHei"/>
+              </a:rPr>
+              <a:t>使用原则：估计模型只用天光光谱和环境特征训练；LED 光谱只在补偿应用中使用，避免数据角色混淆。</a:t>
+            </a:r>
+          </a:p>
+        </p:txBody>
+      </p:sp>
+      <p:sp>
+        <p:nvSpPr>
+          <p:cNvPr id="29" name="TextBox 28"/>
+          <p:cNvSpPr txBox="1"/>
+          <p:nvPr/>
+        </p:nvSpPr>
+        <p:spPr>
+          <a:xfrm>
+            <a:off x="737999" y="4831200"/>
+            <a:ext cx="9792000" cy="162000"/>
+          </a:xfrm>
+          <a:prstGeom prst="rect">
+            <a:avLst/>
+          </a:prstGeom>
+          <a:noFill/>
+        </p:spPr>
+        <p:txBody>
+          <a:bodyPr wrap="square" lIns="0" tIns="0" rIns="0" bIns="0" anchor="t">
+            <a:spAutoFit/>
+          </a:bodyPr>
+          <a:lstStyle/>
+          <a:p>
+            <a:pPr algn="l"/>
+            <a:r>
               <a:rPr sz="930" b="0">
                 <a:solidFill>
                   <a:srgbClr val="737373"/>
                 </a:solidFill>
                 <a:latin typeface="Microsoft YaHei"/>
               </a:rPr>
-              <a:t>说明：天气数据为按地点和时间对齐的历史天气特征，不等同于现场同步气象测量。</a:t>
-            </a:r>
-          </a:p>
-        </p:txBody>
-      </p:sp>
-      <p:sp>
-        <p:nvSpPr>
-          <p:cNvPr id="26" name="TextBox 25"/>
+              <a:t>边界说明：天气数据为按地点和时间对齐的历史天气特征，不等同于现场同步气象测量。</a:t>
+            </a:r>
+          </a:p>
+        </p:txBody>
+      </p:sp>
+      <p:sp>
+        <p:nvSpPr>
+          <p:cNvPr id="30" name="TextBox 29"/>
           <p:cNvSpPr txBox="1"/>
           <p:nvPr/>
         </p:nvSpPr>
@@ -8270,7 +9359,7 @@
       </p:sp>
       <p:sp>
         <p:nvSpPr>
-          <p:cNvPr id="27" name="TextBox 26"/>
+          <p:cNvPr id="31" name="TextBox 30"/>
           <p:cNvSpPr txBox="1"/>
           <p:nvPr/>
         </p:nvSpPr>
@@ -8528,8 +9617,8 @@
         </p:nvSpPr>
         <p:spPr>
           <a:xfrm>
-            <a:off x="503999" y="1522800"/>
-            <a:ext cx="2142000" cy="180000"/>
+            <a:off x="503999" y="1483200"/>
+            <a:ext cx="2142000" cy="151200"/>
           </a:xfrm>
           <a:prstGeom prst="rect">
             <a:avLst/>
@@ -8544,20 +9633,55 @@
           <a:p>
             <a:pPr algn="l"/>
             <a:r>
-              <a:rPr sz="1300" b="1">
+              <a:rPr sz="1240" b="1">
                 <a:solidFill>
                   <a:srgbClr val="0A0A0A"/>
                 </a:solidFill>
                 <a:latin typeface="Microsoft YaHei"/>
               </a:rPr>
               <a:t>数据下载</a:t>
+            </a:r>
+          </a:p>
+        </p:txBody>
+      </p:sp>
+      <p:sp>
+        <p:nvSpPr>
+          <p:cNvPr id="8" name="TextBox 7"/>
+          <p:cNvSpPr txBox="1"/>
+          <p:nvPr/>
+        </p:nvSpPr>
+        <p:spPr>
+          <a:xfrm>
+            <a:off x="503999" y="1684800"/>
+            <a:ext cx="2142000" cy="122400"/>
+          </a:xfrm>
+          <a:prstGeom prst="rect">
+            <a:avLst/>
+          </a:prstGeom>
+          <a:noFill/>
+        </p:spPr>
+        <p:txBody>
+          <a:bodyPr wrap="square" lIns="0" tIns="0" rIns="0" bIns="0" anchor="t">
+            <a:spAutoFit/>
+          </a:bodyPr>
+          <a:lstStyle/>
+          <a:p>
+            <a:pPr algn="l"/>
+            <a:r>
+              <a:rPr sz="810" b="0">
+                <a:solidFill>
+                  <a:srgbClr val="737373"/>
+                </a:solidFill>
+                <a:latin typeface="Consolas"/>
+              </a:rPr>
+              <a:t>SKYSPECTRA/API</a:t>
             </a:r>
           </a:p>
         </p:txBody>
       </p:sp>
       <p:cxnSp>
         <p:nvCxnSpPr>
-          <p:cNvPr id="8" name="Connector 7"/>
+          <p:cNvPr id="9" name="Connector 8"/>
           <p:cNvCxnSpPr/>
           <p:nvPr/>
         </p:nvCxnSpPr>
@@ -8592,7 +9716,7 @@
       </p:cxnSp>
       <p:sp>
         <p:nvSpPr>
-          <p:cNvPr id="9" name="Rectangle 8"/>
+          <p:cNvPr id="10" name="Rectangle 9"/>
           <p:cNvSpPr/>
           <p:nvPr/>
         </p:nvSpPr>
@@ -8635,7 +9759,7 @@
       </p:sp>
       <p:sp>
         <p:nvSpPr>
-          <p:cNvPr id="10" name="TextBox 9"/>
+          <p:cNvPr id="11" name="TextBox 10"/>
           <p:cNvSpPr txBox="1"/>
           <p:nvPr/>
         </p:nvSpPr>
@@ -8670,14 +9794,14 @@
       </p:sp>
       <p:sp>
         <p:nvSpPr>
-          <p:cNvPr id="11" name="TextBox 10"/>
-          <p:cNvSpPr txBox="1"/>
-          <p:nvPr/>
-        </p:nvSpPr>
-        <p:spPr>
-          <a:xfrm>
-            <a:off x="3258000" y="1522800"/>
-            <a:ext cx="2142000" cy="180000"/>
+          <p:cNvPr id="12" name="TextBox 11"/>
+          <p:cNvSpPr txBox="1"/>
+          <p:nvPr/>
+        </p:nvSpPr>
+        <p:spPr>
+          <a:xfrm>
+            <a:off x="3258000" y="1483200"/>
+            <a:ext cx="2142000" cy="151200"/>
           </a:xfrm>
           <a:prstGeom prst="rect">
             <a:avLst/>
@@ -8692,20 +9816,55 @@
           <a:p>
             <a:pPr algn="l"/>
             <a:r>
-              <a:rPr sz="1300" b="1">
+              <a:rPr sz="1240" b="1">
                 <a:solidFill>
                   <a:srgbClr val="0A0A0A"/>
                 </a:solidFill>
                 <a:latin typeface="Microsoft YaHei"/>
               </a:rPr>
               <a:t>清洗重采样</a:t>
+            </a:r>
+          </a:p>
+        </p:txBody>
+      </p:sp>
+      <p:sp>
+        <p:nvSpPr>
+          <p:cNvPr id="13" name="TextBox 12"/>
+          <p:cNvSpPr txBox="1"/>
+          <p:nvPr/>
+        </p:nvSpPr>
+        <p:spPr>
+          <a:xfrm>
+            <a:off x="3258000" y="1684800"/>
+            <a:ext cx="2142000" cy="122400"/>
+          </a:xfrm>
+          <a:prstGeom prst="rect">
+            <a:avLst/>
+          </a:prstGeom>
+          <a:noFill/>
+        </p:spPr>
+        <p:txBody>
+          <a:bodyPr wrap="square" lIns="0" tIns="0" rIns="0" bIns="0" anchor="t">
+            <a:spAutoFit/>
+          </a:bodyPr>
+          <a:lstStyle/>
+          <a:p>
+            <a:pPr algn="l"/>
+            <a:r>
+              <a:rPr sz="810" b="0">
+                <a:solidFill>
+                  <a:srgbClr val="737373"/>
+                </a:solidFill>
+                <a:latin typeface="Consolas"/>
+              </a:rPr>
+              <a:t>统一波长网格</a:t>
             </a:r>
           </a:p>
         </p:txBody>
       </p:sp>
       <p:cxnSp>
         <p:nvCxnSpPr>
-          <p:cNvPr id="12" name="Connector 11"/>
+          <p:cNvPr id="14" name="Connector 13"/>
           <p:cNvCxnSpPr/>
           <p:nvPr/>
         </p:nvCxnSpPr>
@@ -8740,7 +9899,7 @@
       </p:cxnSp>
       <p:sp>
         <p:nvSpPr>
-          <p:cNvPr id="13" name="Rectangle 12"/>
+          <p:cNvPr id="15" name="Rectangle 14"/>
           <p:cNvSpPr/>
           <p:nvPr/>
         </p:nvSpPr>
@@ -8783,7 +9942,7 @@
       </p:sp>
       <p:sp>
         <p:nvSpPr>
-          <p:cNvPr id="14" name="TextBox 13"/>
+          <p:cNvPr id="16" name="TextBox 15"/>
           <p:cNvSpPr txBox="1"/>
           <p:nvPr/>
         </p:nvSpPr>
@@ -8818,14 +9977,14 @@
       </p:sp>
       <p:sp>
         <p:nvSpPr>
-          <p:cNvPr id="15" name="TextBox 14"/>
-          <p:cNvSpPr txBox="1"/>
-          <p:nvPr/>
-        </p:nvSpPr>
-        <p:spPr>
-          <a:xfrm>
-            <a:off x="6012000" y="1522800"/>
-            <a:ext cx="2142000" cy="180000"/>
+          <p:cNvPr id="17" name="TextBox 16"/>
+          <p:cNvSpPr txBox="1"/>
+          <p:nvPr/>
+        </p:nvSpPr>
+        <p:spPr>
+          <a:xfrm>
+            <a:off x="6012000" y="1483200"/>
+            <a:ext cx="2142000" cy="151200"/>
           </a:xfrm>
           <a:prstGeom prst="rect">
             <a:avLst/>
@@ -8840,20 +9999,55 @@
           <a:p>
             <a:pPr algn="l"/>
             <a:r>
-              <a:rPr sz="1300" b="1">
+              <a:rPr sz="1240" b="1">
                 <a:solidFill>
                   <a:srgbClr val="0A0A0A"/>
                 </a:solidFill>
                 <a:latin typeface="Microsoft YaHei"/>
               </a:rPr>
               <a:t>天气对齐</a:t>
+            </a:r>
+          </a:p>
+        </p:txBody>
+      </p:sp>
+      <p:sp>
+        <p:nvSpPr>
+          <p:cNvPr id="18" name="TextBox 17"/>
+          <p:cNvSpPr txBox="1"/>
+          <p:nvPr/>
+        </p:nvSpPr>
+        <p:spPr>
+          <a:xfrm>
+            <a:off x="6012000" y="1684800"/>
+            <a:ext cx="2142000" cy="122400"/>
+          </a:xfrm>
+          <a:prstGeom prst="rect">
+            <a:avLst/>
+          </a:prstGeom>
+          <a:noFill/>
+        </p:spPr>
+        <p:txBody>
+          <a:bodyPr wrap="square" lIns="0" tIns="0" rIns="0" bIns="0" anchor="t">
+            <a:spAutoFit/>
+          </a:bodyPr>
+          <a:lstStyle/>
+          <a:p>
+            <a:pPr algn="l"/>
+            <a:r>
+              <a:rPr sz="810" b="0">
+                <a:solidFill>
+                  <a:srgbClr val="737373"/>
+                </a:solidFill>
+                <a:latin typeface="Consolas"/>
+              </a:rPr>
+              <a:t>最近整点匹配</a:t>
             </a:r>
           </a:p>
         </p:txBody>
       </p:sp>
       <p:cxnSp>
         <p:nvCxnSpPr>
-          <p:cNvPr id="16" name="Connector 15"/>
+          <p:cNvPr id="19" name="Connector 18"/>
           <p:cNvCxnSpPr/>
           <p:nvPr/>
         </p:nvCxnSpPr>
@@ -8888,7 +10082,7 @@
       </p:cxnSp>
       <p:sp>
         <p:nvSpPr>
-          <p:cNvPr id="17" name="Rectangle 16"/>
+          <p:cNvPr id="20" name="Rectangle 19"/>
           <p:cNvSpPr/>
           <p:nvPr/>
         </p:nvSpPr>
@@ -8931,7 +10125,7 @@
       </p:sp>
       <p:sp>
         <p:nvSpPr>
-          <p:cNvPr id="18" name="TextBox 17"/>
+          <p:cNvPr id="21" name="TextBox 20"/>
           <p:cNvSpPr txBox="1"/>
           <p:nvPr/>
         </p:nvSpPr>
@@ -8966,14 +10160,14 @@
       </p:sp>
       <p:sp>
         <p:nvSpPr>
-          <p:cNvPr id="19" name="TextBox 18"/>
-          <p:cNvSpPr txBox="1"/>
-          <p:nvPr/>
-        </p:nvSpPr>
-        <p:spPr>
-          <a:xfrm>
-            <a:off x="8766000" y="1522800"/>
-            <a:ext cx="2142000" cy="180000"/>
+          <p:cNvPr id="22" name="TextBox 21"/>
+          <p:cNvSpPr txBox="1"/>
+          <p:nvPr/>
+        </p:nvSpPr>
+        <p:spPr>
+          <a:xfrm>
+            <a:off x="8766000" y="1483200"/>
+            <a:ext cx="2142000" cy="151200"/>
           </a:xfrm>
           <a:prstGeom prst="rect">
             <a:avLst/>
@@ -8988,20 +10182,55 @@
           <a:p>
             <a:pPr algn="l"/>
             <a:r>
-              <a:rPr sz="1300" b="1">
+              <a:rPr sz="1240" b="1">
                 <a:solidFill>
                   <a:srgbClr val="0A0A0A"/>
                 </a:solidFill>
                 <a:latin typeface="Microsoft YaHei"/>
               </a:rPr>
               <a:t>特征工程</a:t>
+            </a:r>
+          </a:p>
+        </p:txBody>
+      </p:sp>
+      <p:sp>
+        <p:nvSpPr>
+          <p:cNvPr id="23" name="TextBox 22"/>
+          <p:cNvSpPr txBox="1"/>
+          <p:nvPr/>
+        </p:nvSpPr>
+        <p:spPr>
+          <a:xfrm>
+            <a:off x="8766000" y="1684800"/>
+            <a:ext cx="2142000" cy="122400"/>
+          </a:xfrm>
+          <a:prstGeom prst="rect">
+            <a:avLst/>
+          </a:prstGeom>
+          <a:noFill/>
+        </p:spPr>
+        <p:txBody>
+          <a:bodyPr wrap="square" lIns="0" tIns="0" rIns="0" bIns="0" anchor="t">
+            <a:spAutoFit/>
+          </a:bodyPr>
+          <a:lstStyle/>
+          <a:p>
+            <a:pPr algn="l"/>
+            <a:r>
+              <a:rPr sz="810" b="0">
+                <a:solidFill>
+                  <a:srgbClr val="737373"/>
+                </a:solidFill>
+                <a:latin typeface="Consolas"/>
+              </a:rPr>
+              <a:t>标准化/独热编码</a:t>
             </a:r>
           </a:p>
         </p:txBody>
       </p:sp>
       <p:cxnSp>
         <p:nvCxnSpPr>
-          <p:cNvPr id="20" name="Connector 19"/>
+          <p:cNvPr id="24" name="Connector 23"/>
           <p:cNvCxnSpPr/>
           <p:nvPr/>
         </p:nvCxnSpPr>
@@ -9036,7 +10265,7 @@
       </p:cxnSp>
       <p:sp>
         <p:nvSpPr>
-          <p:cNvPr id="21" name="Rectangle 20"/>
+          <p:cNvPr id="25" name="Rectangle 24"/>
           <p:cNvSpPr/>
           <p:nvPr/>
         </p:nvSpPr>
@@ -9079,7 +10308,7 @@
       </p:sp>
       <p:sp>
         <p:nvSpPr>
-          <p:cNvPr id="22" name="TextBox 21"/>
+          <p:cNvPr id="26" name="TextBox 25"/>
           <p:cNvSpPr txBox="1"/>
           <p:nvPr/>
         </p:nvSpPr>
@@ -9114,14 +10343,14 @@
       </p:sp>
       <p:sp>
         <p:nvSpPr>
-          <p:cNvPr id="23" name="TextBox 22"/>
-          <p:cNvSpPr txBox="1"/>
-          <p:nvPr/>
-        </p:nvSpPr>
-        <p:spPr>
-          <a:xfrm>
-            <a:off x="8766000" y="3124800"/>
-            <a:ext cx="2142000" cy="180000"/>
+          <p:cNvPr id="27" name="TextBox 26"/>
+          <p:cNvSpPr txBox="1"/>
+          <p:nvPr/>
+        </p:nvSpPr>
+        <p:spPr>
+          <a:xfrm>
+            <a:off x="8766000" y="3085200"/>
+            <a:ext cx="2142000" cy="151200"/>
           </a:xfrm>
           <a:prstGeom prst="rect">
             <a:avLst/>
@@ -9136,20 +10365,55 @@
           <a:p>
             <a:pPr algn="l"/>
             <a:r>
-              <a:rPr sz="1300" b="1">
+              <a:rPr sz="1240" b="1">
                 <a:solidFill>
                   <a:srgbClr val="FFFFFF"/>
                 </a:solidFill>
                 <a:latin typeface="Microsoft YaHei"/>
               </a:rPr>
               <a:t>PCA</a:t>
+            </a:r>
+          </a:p>
+        </p:txBody>
+      </p:sp>
+      <p:sp>
+        <p:nvSpPr>
+          <p:cNvPr id="28" name="TextBox 27"/>
+          <p:cNvSpPr txBox="1"/>
+          <p:nvPr/>
+        </p:nvSpPr>
+        <p:spPr>
+          <a:xfrm>
+            <a:off x="8766000" y="3286800"/>
+            <a:ext cx="2142000" cy="122400"/>
+          </a:xfrm>
+          <a:prstGeom prst="rect">
+            <a:avLst/>
+          </a:prstGeom>
+          <a:noFill/>
+        </p:spPr>
+        <p:txBody>
+          <a:bodyPr wrap="square" lIns="0" tIns="0" rIns="0" bIns="0" anchor="t">
+            <a:spAutoFit/>
+          </a:bodyPr>
+          <a:lstStyle/>
+          <a:p>
+            <a:pPr algn="l"/>
+            <a:r>
+              <a:rPr sz="810" b="0">
+                <a:solidFill>
+                  <a:srgbClr val="FFFFFF"/>
+                </a:solidFill>
+                <a:latin typeface="Consolas"/>
+              </a:rPr>
+              <a:t>41 维降到 5 维</a:t>
             </a:r>
           </a:p>
         </p:txBody>
       </p:sp>
       <p:cxnSp>
         <p:nvCxnSpPr>
-          <p:cNvPr id="24" name="Connector 23"/>
+          <p:cNvPr id="29" name="Connector 28"/>
           <p:cNvCxnSpPr/>
           <p:nvPr/>
         </p:nvCxnSpPr>
@@ -9184,7 +10448,7 @@
       </p:cxnSp>
       <p:sp>
         <p:nvSpPr>
-          <p:cNvPr id="25" name="Rectangle 24"/>
+          <p:cNvPr id="30" name="Rectangle 29"/>
           <p:cNvSpPr/>
           <p:nvPr/>
         </p:nvSpPr>
@@ -9227,7 +10491,7 @@
       </p:sp>
       <p:sp>
         <p:nvSpPr>
-          <p:cNvPr id="26" name="TextBox 25"/>
+          <p:cNvPr id="31" name="TextBox 30"/>
           <p:cNvSpPr txBox="1"/>
           <p:nvPr/>
         </p:nvSpPr>
@@ -9262,14 +10526,14 @@
       </p:sp>
       <p:sp>
         <p:nvSpPr>
-          <p:cNvPr id="27" name="TextBox 26"/>
-          <p:cNvSpPr txBox="1"/>
-          <p:nvPr/>
-        </p:nvSpPr>
-        <p:spPr>
-          <a:xfrm>
-            <a:off x="6012000" y="3124800"/>
-            <a:ext cx="2142000" cy="180000"/>
+          <p:cNvPr id="32" name="TextBox 31"/>
+          <p:cNvSpPr txBox="1"/>
+          <p:nvPr/>
+        </p:nvSpPr>
+        <p:spPr>
+          <a:xfrm>
+            <a:off x="6012000" y="3085200"/>
+            <a:ext cx="2142000" cy="151200"/>
           </a:xfrm>
           <a:prstGeom prst="rect">
             <a:avLst/>
@@ -9284,20 +10548,55 @@
           <a:p>
             <a:pPr algn="l"/>
             <a:r>
-              <a:rPr sz="1300" b="1">
+              <a:rPr sz="1240" b="1">
                 <a:solidFill>
                   <a:srgbClr val="0A0A0A"/>
                 </a:solidFill>
                 <a:latin typeface="Microsoft YaHei"/>
               </a:rPr>
               <a:t>五模型训练</a:t>
+            </a:r>
+          </a:p>
+        </p:txBody>
+      </p:sp>
+      <p:sp>
+        <p:nvSpPr>
+          <p:cNvPr id="33" name="TextBox 32"/>
+          <p:cNvSpPr txBox="1"/>
+          <p:nvPr/>
+        </p:nvSpPr>
+        <p:spPr>
+          <a:xfrm>
+            <a:off x="6012000" y="3286800"/>
+            <a:ext cx="2142000" cy="122400"/>
+          </a:xfrm>
+          <a:prstGeom prst="rect">
+            <a:avLst/>
+          </a:prstGeom>
+          <a:noFill/>
+        </p:spPr>
+        <p:txBody>
+          <a:bodyPr wrap="square" lIns="0" tIns="0" rIns="0" bIns="0" anchor="t">
+            <a:spAutoFit/>
+          </a:bodyPr>
+          <a:lstStyle/>
+          <a:p>
+            <a:pPr algn="l"/>
+            <a:r>
+              <a:rPr sz="810" b="0">
+                <a:solidFill>
+                  <a:srgbClr val="737373"/>
+                </a:solidFill>
+                <a:latin typeface="Consolas"/>
+              </a:rPr>
+              <a:t>统一指标对比</a:t>
             </a:r>
           </a:p>
         </p:txBody>
       </p:sp>
       <p:cxnSp>
         <p:nvCxnSpPr>
-          <p:cNvPr id="28" name="Connector 27"/>
+          <p:cNvPr id="34" name="Connector 33"/>
           <p:cNvCxnSpPr/>
           <p:nvPr/>
         </p:nvCxnSpPr>
@@ -9332,7 +10631,7 @@
       </p:cxnSp>
       <p:sp>
         <p:nvSpPr>
-          <p:cNvPr id="29" name="Rectangle 28"/>
+          <p:cNvPr id="35" name="Rectangle 34"/>
           <p:cNvSpPr/>
           <p:nvPr/>
         </p:nvSpPr>
@@ -9375,7 +10674,7 @@
       </p:sp>
       <p:sp>
         <p:nvSpPr>
-          <p:cNvPr id="30" name="TextBox 29"/>
+          <p:cNvPr id="36" name="TextBox 35"/>
           <p:cNvSpPr txBox="1"/>
           <p:nvPr/>
         </p:nvSpPr>
@@ -9410,14 +10709,14 @@
       </p:sp>
       <p:sp>
         <p:nvSpPr>
-          <p:cNvPr id="31" name="TextBox 30"/>
-          <p:cNvSpPr txBox="1"/>
-          <p:nvPr/>
-        </p:nvSpPr>
-        <p:spPr>
-          <a:xfrm>
-            <a:off x="3258000" y="3124800"/>
-            <a:ext cx="2142000" cy="180000"/>
+          <p:cNvPr id="37" name="TextBox 36"/>
+          <p:cNvSpPr txBox="1"/>
+          <p:nvPr/>
+        </p:nvSpPr>
+        <p:spPr>
+          <a:xfrm>
+            <a:off x="3258000" y="3085200"/>
+            <a:ext cx="2142000" cy="151200"/>
           </a:xfrm>
           <a:prstGeom prst="rect">
             <a:avLst/>
@@ -9432,20 +10731,55 @@
           <a:p>
             <a:pPr algn="l"/>
             <a:r>
-              <a:rPr sz="1300" b="1">
+              <a:rPr sz="1240" b="1">
                 <a:solidFill>
                   <a:srgbClr val="0A0A0A"/>
                 </a:solidFill>
                 <a:latin typeface="Microsoft YaHei"/>
               </a:rPr>
               <a:t>光谱还原</a:t>
+            </a:r>
+          </a:p>
+        </p:txBody>
+      </p:sp>
+      <p:sp>
+        <p:nvSpPr>
+          <p:cNvPr id="38" name="TextBox 37"/>
+          <p:cNvSpPr txBox="1"/>
+          <p:nvPr/>
+        </p:nvSpPr>
+        <p:spPr>
+          <a:xfrm>
+            <a:off x="3258000" y="3286800"/>
+            <a:ext cx="2142000" cy="122400"/>
+          </a:xfrm>
+          <a:prstGeom prst="rect">
+            <a:avLst/>
+          </a:prstGeom>
+          <a:noFill/>
+        </p:spPr>
+        <p:txBody>
+          <a:bodyPr wrap="square" lIns="0" tIns="0" rIns="0" bIns="0" anchor="t">
+            <a:spAutoFit/>
+          </a:bodyPr>
+          <a:lstStyle/>
+          <a:p>
+            <a:pPr algn="l"/>
+            <a:r>
+              <a:rPr sz="810" b="0">
+                <a:solidFill>
+                  <a:srgbClr val="737373"/>
+                </a:solidFill>
+                <a:latin typeface="Consolas"/>
+              </a:rPr>
+              <a:t>inverse transform</a:t>
             </a:r>
           </a:p>
         </p:txBody>
       </p:sp>
       <p:cxnSp>
         <p:nvCxnSpPr>
-          <p:cNvPr id="32" name="Connector 31"/>
+          <p:cNvPr id="39" name="Connector 38"/>
           <p:cNvCxnSpPr/>
           <p:nvPr/>
         </p:nvCxnSpPr>
@@ -9480,7 +10814,7 @@
       </p:cxnSp>
       <p:sp>
         <p:nvSpPr>
-          <p:cNvPr id="33" name="Rectangle 32"/>
+          <p:cNvPr id="40" name="Rectangle 39"/>
           <p:cNvSpPr/>
           <p:nvPr/>
         </p:nvSpPr>
@@ -9523,7 +10857,7 @@
       </p:sp>
       <p:sp>
         <p:nvSpPr>
-          <p:cNvPr id="34" name="TextBox 33"/>
+          <p:cNvPr id="41" name="TextBox 40"/>
           <p:cNvSpPr txBox="1"/>
           <p:nvPr/>
         </p:nvSpPr>
@@ -9558,14 +10892,14 @@
       </p:sp>
       <p:sp>
         <p:nvSpPr>
-          <p:cNvPr id="35" name="TextBox 34"/>
-          <p:cNvSpPr txBox="1"/>
-          <p:nvPr/>
-        </p:nvSpPr>
-        <p:spPr>
-          <a:xfrm>
-            <a:off x="503999" y="3124800"/>
-            <a:ext cx="2142000" cy="180000"/>
+          <p:cNvPr id="42" name="TextBox 41"/>
+          <p:cNvSpPr txBox="1"/>
+          <p:nvPr/>
+        </p:nvSpPr>
+        <p:spPr>
+          <a:xfrm>
+            <a:off x="503999" y="3085200"/>
+            <a:ext cx="2142000" cy="151200"/>
           </a:xfrm>
           <a:prstGeom prst="rect">
             <a:avLst/>
@@ -9580,7 +10914,7 @@
           <a:p>
             <a:pPr algn="l"/>
             <a:r>
-              <a:rPr sz="1300" b="1">
+              <a:rPr sz="1240" b="1">
                 <a:solidFill>
                   <a:srgbClr val="FFFFFF"/>
                 </a:solidFill>
@@ -9593,7 +10927,42 @@
       </p:sp>
       <p:sp>
         <p:nvSpPr>
-          <p:cNvPr id="36" name="Rectangle 35"/>
+          <p:cNvPr id="43" name="TextBox 42"/>
+          <p:cNvSpPr txBox="1"/>
+          <p:nvPr/>
+        </p:nvSpPr>
+        <p:spPr>
+          <a:xfrm>
+            <a:off x="503999" y="3286800"/>
+            <a:ext cx="2142000" cy="122400"/>
+          </a:xfrm>
+          <a:prstGeom prst="rect">
+            <a:avLst/>
+          </a:prstGeom>
+          <a:noFill/>
+        </p:spPr>
+        <p:txBody>
+          <a:bodyPr wrap="square" lIns="0" tIns="0" rIns="0" bIns="0" anchor="t">
+            <a:spAutoFit/>
+          </a:bodyPr>
+          <a:lstStyle/>
+          <a:p>
+            <a:pPr algn="l"/>
+            <a:r>
+              <a:rPr sz="810" b="0">
+                <a:solidFill>
+                  <a:srgbClr val="FFFFFF"/>
+                </a:solidFill>
+                <a:latin typeface="Consolas"/>
+              </a:rPr>
+              <a:t>七通道比例</a:t>
+            </a:r>
+          </a:p>
+        </p:txBody>
+      </p:sp>
+      <p:sp>
+        <p:nvSpPr>
+          <p:cNvPr id="44" name="Rectangle 43"/>
           <p:cNvSpPr/>
           <p:nvPr/>
         </p:nvSpPr>
@@ -9638,13 +11007,13 @@
       </p:sp>
       <p:sp>
         <p:nvSpPr>
-          <p:cNvPr id="37" name="TextBox 36"/>
-          <p:cNvSpPr txBox="1"/>
-          <p:nvPr/>
-        </p:nvSpPr>
-        <p:spPr>
-          <a:xfrm>
-            <a:off x="558000" y="5004000"/>
+          <p:cNvPr id="45" name="TextBox 44"/>
+          <p:cNvSpPr txBox="1"/>
+          <p:nvPr/>
+        </p:nvSpPr>
+        <p:spPr>
+          <a:xfrm>
+            <a:off x="558000" y="4917600"/>
             <a:ext cx="10332000" cy="151200"/>
           </a:xfrm>
           <a:prstGeom prst="rect">
@@ -9660,7 +11029,7 @@
           <a:p>
             <a:pPr algn="l"/>
             <a:r>
-              <a:rPr sz="1160" b="1">
+              <a:rPr sz="1130" b="1">
                 <a:solidFill>
                   <a:srgbClr val="0A0A0A"/>
                 </a:solidFill>
@@ -9673,7 +11042,159 @@
       </p:sp>
       <p:sp>
         <p:nvSpPr>
-          <p:cNvPr id="38" name="TextBox 37"/>
+          <p:cNvPr id="46" name="TextBox 45"/>
+          <p:cNvSpPr txBox="1"/>
+          <p:nvPr/>
+        </p:nvSpPr>
+        <p:spPr>
+          <a:xfrm>
+            <a:off x="558000" y="5158800"/>
+            <a:ext cx="10332000" cy="136800"/>
+          </a:xfrm>
+          <a:prstGeom prst="rect">
+            <a:avLst/>
+          </a:prstGeom>
+          <a:noFill/>
+        </p:spPr>
+        <p:txBody>
+          <a:bodyPr wrap="square" lIns="0" tIns="0" rIns="0" bIns="0" anchor="t">
+            <a:spAutoFit/>
+          </a:bodyPr>
+          <a:lstStyle/>
+          <a:p>
+            <a:pPr algn="l"/>
+            <a:r>
+              <a:rPr sz="930" b="0">
+                <a:solidFill>
+                  <a:srgbClr val="737373"/>
+                </a:solidFill>
+                <a:latin typeface="Microsoft YaHei"/>
+              </a:rPr>
+              <a:t>流程特点：每一步都有对应的数据、模型或图表输出，能够支撑完整的课程演示。</a:t>
+            </a:r>
+          </a:p>
+        </p:txBody>
+      </p:sp>
+      <p:sp>
+        <p:nvSpPr>
+          <p:cNvPr id="47" name="Rectangle 46"/>
+          <p:cNvSpPr/>
+          <p:nvPr/>
+        </p:nvSpPr>
+        <p:spPr>
+          <a:xfrm>
+            <a:off x="378000" y="3834000"/>
+            <a:ext cx="10800000" cy="684000"/>
+          </a:xfrm>
+          <a:prstGeom prst="rect">
+            <a:avLst/>
+          </a:prstGeom>
+          <a:solidFill>
+            <a:srgbClr val="F0F0EE"/>
+          </a:solidFill>
+          <a:ln>
+            <a:noFill/>
+          </a:ln>
+        </p:spPr>
+        <p:style>
+          <a:lnRef idx="1">
+            <a:schemeClr val="accent1"/>
+          </a:lnRef>
+          <a:fillRef idx="3">
+            <a:schemeClr val="accent1"/>
+          </a:fillRef>
+          <a:effectRef idx="2">
+            <a:schemeClr val="accent1"/>
+          </a:effectRef>
+          <a:fontRef idx="minor">
+            <a:schemeClr val="lt1"/>
+          </a:fontRef>
+        </p:style>
+        <p:txBody>
+          <a:bodyPr rtlCol="0" anchor="ctr"/>
+          <a:lstStyle/>
+          <a:p>
+            <a:pPr algn="ctr"/>
+          </a:p>
+        </p:txBody>
+      </p:sp>
+      <p:sp>
+        <p:nvSpPr>
+          <p:cNvPr id="48" name="TextBox 47"/>
+          <p:cNvSpPr txBox="1"/>
+          <p:nvPr/>
+        </p:nvSpPr>
+        <p:spPr>
+          <a:xfrm>
+            <a:off x="503999" y="3924000"/>
+            <a:ext cx="10548000" cy="122400"/>
+          </a:xfrm>
+          <a:prstGeom prst="rect">
+            <a:avLst/>
+          </a:prstGeom>
+          <a:noFill/>
+        </p:spPr>
+        <p:txBody>
+          <a:bodyPr wrap="square" lIns="0" tIns="0" rIns="0" bIns="0" anchor="t">
+            <a:spAutoFit/>
+          </a:bodyPr>
+          <a:lstStyle/>
+          <a:p>
+            <a:pPr algn="l"/>
+            <a:r>
+              <a:rPr sz="940" b="1">
+                <a:solidFill>
+                  <a:srgbClr val="002FA7"/>
+                </a:solidFill>
+                <a:latin typeface="Microsoft YaHei"/>
+              </a:rPr>
+              <a:t>流程关系</a:t>
+            </a:r>
+          </a:p>
+        </p:txBody>
+      </p:sp>
+      <p:sp>
+        <p:nvSpPr>
+          <p:cNvPr id="49" name="TextBox 48"/>
+          <p:cNvSpPr txBox="1"/>
+          <p:nvPr/>
+        </p:nvSpPr>
+        <p:spPr>
+          <a:xfrm>
+            <a:off x="503999" y="4114800"/>
+            <a:ext cx="10548000" cy="352799"/>
+          </a:xfrm>
+          <a:prstGeom prst="rect">
+            <a:avLst/>
+          </a:prstGeom>
+          <a:noFill/>
+        </p:spPr>
+        <p:txBody>
+          <a:bodyPr wrap="square" lIns="0" tIns="0" rIns="0" bIns="0" anchor="t">
+            <a:spAutoFit/>
+          </a:bodyPr>
+          <a:lstStyle/>
+          <a:p>
+            <a:pPr algn="l">
+              <a:lnSpc>
+                <a:spcPct val="103000"/>
+              </a:lnSpc>
+            </a:pPr>
+            <a:r>
+              <a:rPr sz="869" b="0">
+                <a:solidFill>
+                  <a:srgbClr val="0A0A0A"/>
+                </a:solidFill>
+                <a:latin typeface="Microsoft YaHei"/>
+              </a:rPr>
+              <a:t>前半部分把真实数据整理成训练集，中间用 PCA 和回归模型完成光谱估计，后半部分把预测结果接到照明补偿应用里。</a:t>
+            </a:r>
+          </a:p>
+        </p:txBody>
+      </p:sp>
+      <p:sp>
+        <p:nvSpPr>
+          <p:cNvPr id="50" name="TextBox 49"/>
           <p:cNvSpPr txBox="1"/>
           <p:nvPr/>
         </p:nvSpPr>
@@ -9708,7 +11229,7 @@
       </p:sp>
       <p:sp>
         <p:nvSpPr>
-          <p:cNvPr id="39" name="TextBox 38"/>
+          <p:cNvPr id="51" name="TextBox 50"/>
           <p:cNvSpPr txBox="1"/>
           <p:nvPr/>
         </p:nvSpPr>
@@ -10006,8 +11527,242 @@
         </p:nvSpPr>
         <p:spPr>
           <a:xfrm>
-            <a:off x="360000" y="4698000"/>
-            <a:ext cx="10800000" cy="737999"/>
+            <a:off x="360000" y="4392000"/>
+            <a:ext cx="5040000" cy="619200"/>
+          </a:xfrm>
+          <a:prstGeom prst="rect">
+            <a:avLst/>
+          </a:prstGeom>
+          <a:solidFill>
+            <a:srgbClr val="FAFAF8"/>
+          </a:solidFill>
+          <a:ln>
+            <a:noFill/>
+          </a:ln>
+        </p:spPr>
+        <p:style>
+          <a:lnRef idx="1">
+            <a:schemeClr val="accent1"/>
+          </a:lnRef>
+          <a:fillRef idx="3">
+            <a:schemeClr val="accent1"/>
+          </a:fillRef>
+          <a:effectRef idx="2">
+            <a:schemeClr val="accent1"/>
+          </a:effectRef>
+          <a:fontRef idx="minor">
+            <a:schemeClr val="lt1"/>
+          </a:fontRef>
+        </p:style>
+        <p:txBody>
+          <a:bodyPr rtlCol="0" anchor="ctr"/>
+          <a:lstStyle/>
+          <a:p>
+            <a:pPr algn="ctr"/>
+          </a:p>
+        </p:txBody>
+      </p:sp>
+      <p:sp>
+        <p:nvSpPr>
+          <p:cNvPr id="10" name="TextBox 9"/>
+          <p:cNvSpPr txBox="1"/>
+          <p:nvPr/>
+        </p:nvSpPr>
+        <p:spPr>
+          <a:xfrm>
+            <a:off x="486000" y="4482000"/>
+            <a:ext cx="4788000" cy="122400"/>
+          </a:xfrm>
+          <a:prstGeom prst="rect">
+            <a:avLst/>
+          </a:prstGeom>
+          <a:noFill/>
+        </p:spPr>
+        <p:txBody>
+          <a:bodyPr wrap="square" lIns="0" tIns="0" rIns="0" bIns="0" anchor="t">
+            <a:spAutoFit/>
+          </a:bodyPr>
+          <a:lstStyle/>
+          <a:p>
+            <a:pPr algn="l"/>
+            <a:r>
+              <a:rPr sz="940" b="1">
+                <a:solidFill>
+                  <a:srgbClr val="002FA7"/>
+                </a:solidFill>
+                <a:latin typeface="Microsoft YaHei"/>
+              </a:rPr>
+              <a:t>为什么要 PCA</a:t>
+            </a:r>
+          </a:p>
+        </p:txBody>
+      </p:sp>
+      <p:sp>
+        <p:nvSpPr>
+          <p:cNvPr id="11" name="TextBox 10"/>
+          <p:cNvSpPr txBox="1"/>
+          <p:nvPr/>
+        </p:nvSpPr>
+        <p:spPr>
+          <a:xfrm>
+            <a:off x="486000" y="4672799"/>
+            <a:ext cx="4788000" cy="288000"/>
+          </a:xfrm>
+          <a:prstGeom prst="rect">
+            <a:avLst/>
+          </a:prstGeom>
+          <a:noFill/>
+        </p:spPr>
+        <p:txBody>
+          <a:bodyPr wrap="square" lIns="0" tIns="0" rIns="0" bIns="0" anchor="t">
+            <a:spAutoFit/>
+          </a:bodyPr>
+          <a:lstStyle/>
+          <a:p>
+            <a:pPr algn="l">
+              <a:lnSpc>
+                <a:spcPct val="103000"/>
+              </a:lnSpc>
+            </a:pPr>
+            <a:r>
+              <a:rPr sz="869" b="0">
+                <a:solidFill>
+                  <a:srgbClr val="0A0A0A"/>
+                </a:solidFill>
+                <a:latin typeface="Microsoft YaHei"/>
+              </a:rPr>
+              <a:t>光谱曲线相邻波长之间变化连续、相关性强，直接预测 41 个输出值会增加模型难度。PCA 把主要变化压缩成少量系数，既保留形状信息，也便于回归模型学习。</a:t>
+            </a:r>
+          </a:p>
+        </p:txBody>
+      </p:sp>
+      <p:sp>
+        <p:nvSpPr>
+          <p:cNvPr id="12" name="Rectangle 11"/>
+          <p:cNvSpPr/>
+          <p:nvPr/>
+        </p:nvSpPr>
+        <p:spPr>
+          <a:xfrm>
+            <a:off x="6012000" y="4392000"/>
+            <a:ext cx="5112000" cy="619200"/>
+          </a:xfrm>
+          <a:prstGeom prst="rect">
+            <a:avLst/>
+          </a:prstGeom>
+          <a:solidFill>
+            <a:srgbClr val="FAFAF8"/>
+          </a:solidFill>
+          <a:ln>
+            <a:noFill/>
+          </a:ln>
+        </p:spPr>
+        <p:style>
+          <a:lnRef idx="1">
+            <a:schemeClr val="accent1"/>
+          </a:lnRef>
+          <a:fillRef idx="3">
+            <a:schemeClr val="accent1"/>
+          </a:fillRef>
+          <a:effectRef idx="2">
+            <a:schemeClr val="accent1"/>
+          </a:effectRef>
+          <a:fontRef idx="minor">
+            <a:schemeClr val="lt1"/>
+          </a:fontRef>
+        </p:style>
+        <p:txBody>
+          <a:bodyPr rtlCol="0" anchor="ctr"/>
+          <a:lstStyle/>
+          <a:p>
+            <a:pPr algn="ctr"/>
+          </a:p>
+        </p:txBody>
+      </p:sp>
+      <p:sp>
+        <p:nvSpPr>
+          <p:cNvPr id="13" name="TextBox 12"/>
+          <p:cNvSpPr txBox="1"/>
+          <p:nvPr/>
+        </p:nvSpPr>
+        <p:spPr>
+          <a:xfrm>
+            <a:off x="6138000" y="4482000"/>
+            <a:ext cx="4860000" cy="122400"/>
+          </a:xfrm>
+          <a:prstGeom prst="rect">
+            <a:avLst/>
+          </a:prstGeom>
+          <a:noFill/>
+        </p:spPr>
+        <p:txBody>
+          <a:bodyPr wrap="square" lIns="0" tIns="0" rIns="0" bIns="0" anchor="t">
+            <a:spAutoFit/>
+          </a:bodyPr>
+          <a:lstStyle/>
+          <a:p>
+            <a:pPr algn="l"/>
+            <a:r>
+              <a:rPr sz="940" b="1">
+                <a:solidFill>
+                  <a:srgbClr val="002FA7"/>
+                </a:solidFill>
+                <a:latin typeface="Microsoft YaHei"/>
+              </a:rPr>
+              <a:t>特征怎么理解</a:t>
+            </a:r>
+          </a:p>
+        </p:txBody>
+      </p:sp>
+      <p:sp>
+        <p:nvSpPr>
+          <p:cNvPr id="14" name="TextBox 13"/>
+          <p:cNvSpPr txBox="1"/>
+          <p:nvPr/>
+        </p:nvSpPr>
+        <p:spPr>
+          <a:xfrm>
+            <a:off x="6138000" y="4672799"/>
+            <a:ext cx="4860000" cy="288000"/>
+          </a:xfrm>
+          <a:prstGeom prst="rect">
+            <a:avLst/>
+          </a:prstGeom>
+          <a:noFill/>
+        </p:spPr>
+        <p:txBody>
+          <a:bodyPr wrap="square" lIns="0" tIns="0" rIns="0" bIns="0" anchor="t">
+            <a:spAutoFit/>
+          </a:bodyPr>
+          <a:lstStyle/>
+          <a:p>
+            <a:pPr algn="l">
+              <a:lnSpc>
+                <a:spcPct val="103000"/>
+              </a:lnSpc>
+            </a:pPr>
+            <a:r>
+              <a:rPr sz="869" b="0">
+                <a:solidFill>
+                  <a:srgbClr val="0A0A0A"/>
+                </a:solidFill>
+                <a:latin typeface="Microsoft YaHei"/>
+              </a:rPr>
+              <a:t>特征重要性不是物理因果结论，只说明在当前数据和随机森林模型中，室外照度、云量、太阳方位角等信息对预测光谱形状更有帮助。</a:t>
+            </a:r>
+          </a:p>
+        </p:txBody>
+      </p:sp>
+      <p:sp>
+        <p:nvSpPr>
+          <p:cNvPr id="15" name="Rectangle 14"/>
+          <p:cNvSpPr/>
+          <p:nvPr/>
+        </p:nvSpPr>
+        <p:spPr>
+          <a:xfrm>
+            <a:off x="360000" y="5130000"/>
+            <a:ext cx="10800000" cy="486000"/>
           </a:xfrm>
           <a:prstGeom prst="rect">
             <a:avLst/>
@@ -10043,13 +11798,13 @@
       </p:sp>
       <p:sp>
         <p:nvSpPr>
-          <p:cNvPr id="10" name="Rectangle 9"/>
+          <p:cNvPr id="16" name="Rectangle 15"/>
           <p:cNvSpPr/>
           <p:nvPr/>
         </p:nvSpPr>
         <p:spPr>
           <a:xfrm>
-            <a:off x="522000" y="4917600"/>
+            <a:off x="522000" y="5259600"/>
             <a:ext cx="46800" cy="46800"/>
           </a:xfrm>
           <a:prstGeom prst="rect">
@@ -10086,14 +11841,14 @@
       </p:sp>
       <p:sp>
         <p:nvSpPr>
-          <p:cNvPr id="11" name="TextBox 10"/>
-          <p:cNvSpPr txBox="1"/>
-          <p:nvPr/>
-        </p:nvSpPr>
-        <p:spPr>
-          <a:xfrm>
-            <a:off x="644400" y="4860000"/>
-            <a:ext cx="10065600" cy="251999"/>
+          <p:cNvPr id="17" name="TextBox 16"/>
+          <p:cNvSpPr txBox="1"/>
+          <p:nvPr/>
+        </p:nvSpPr>
+        <p:spPr>
+          <a:xfrm>
+            <a:off x="644400" y="5202000"/>
+            <a:ext cx="10065600" cy="136800"/>
           </a:xfrm>
           <a:prstGeom prst="rect">
             <a:avLst/>
@@ -10112,7 +11867,7 @@
               </a:lnSpc>
             </a:pPr>
             <a:r>
-              <a:rPr sz="1019" b="0">
+              <a:rPr sz="840" b="0">
                 <a:solidFill>
                   <a:srgbClr val="0A0A0A"/>
                 </a:solidFill>
@@ -10125,13 +11880,13 @@
       </p:sp>
       <p:sp>
         <p:nvSpPr>
-          <p:cNvPr id="12" name="Rectangle 11"/>
+          <p:cNvPr id="18" name="Rectangle 17"/>
           <p:cNvSpPr/>
           <p:nvPr/>
         </p:nvSpPr>
         <p:spPr>
           <a:xfrm>
-            <a:off x="522000" y="5169600"/>
+            <a:off x="522000" y="5396400"/>
             <a:ext cx="46800" cy="46800"/>
           </a:xfrm>
           <a:prstGeom prst="rect">
@@ -10168,14 +11923,14 @@
       </p:sp>
       <p:sp>
         <p:nvSpPr>
-          <p:cNvPr id="13" name="TextBox 12"/>
-          <p:cNvSpPr txBox="1"/>
-          <p:nvPr/>
-        </p:nvSpPr>
-        <p:spPr>
-          <a:xfrm>
-            <a:off x="644400" y="5112000"/>
-            <a:ext cx="10065600" cy="251999"/>
+          <p:cNvPr id="19" name="TextBox 18"/>
+          <p:cNvSpPr txBox="1"/>
+          <p:nvPr/>
+        </p:nvSpPr>
+        <p:spPr>
+          <a:xfrm>
+            <a:off x="644400" y="5338800"/>
+            <a:ext cx="10065600" cy="136800"/>
           </a:xfrm>
           <a:prstGeom prst="rect">
             <a:avLst/>
@@ -10194,7 +11949,7 @@
               </a:lnSpc>
             </a:pPr>
             <a:r>
-              <a:rPr sz="1019" b="0">
+              <a:rPr sz="840" b="0">
                 <a:solidFill>
                   <a:srgbClr val="0A0A0A"/>
                 </a:solidFill>
@@ -10207,7 +11962,89 @@
       </p:sp>
       <p:sp>
         <p:nvSpPr>
-          <p:cNvPr id="14" name="TextBox 13"/>
+          <p:cNvPr id="20" name="Rectangle 19"/>
+          <p:cNvSpPr/>
+          <p:nvPr/>
+        </p:nvSpPr>
+        <p:spPr>
+          <a:xfrm>
+            <a:off x="522000" y="5533200"/>
+            <a:ext cx="46800" cy="46800"/>
+          </a:xfrm>
+          <a:prstGeom prst="rect">
+            <a:avLst/>
+          </a:prstGeom>
+          <a:solidFill>
+            <a:srgbClr val="002FA7"/>
+          </a:solidFill>
+          <a:ln>
+            <a:noFill/>
+          </a:ln>
+        </p:spPr>
+        <p:style>
+          <a:lnRef idx="1">
+            <a:schemeClr val="accent1"/>
+          </a:lnRef>
+          <a:fillRef idx="3">
+            <a:schemeClr val="accent1"/>
+          </a:fillRef>
+          <a:effectRef idx="2">
+            <a:schemeClr val="accent1"/>
+          </a:effectRef>
+          <a:fontRef idx="minor">
+            <a:schemeClr val="lt1"/>
+          </a:fontRef>
+        </p:style>
+        <p:txBody>
+          <a:bodyPr rtlCol="0" anchor="ctr"/>
+          <a:lstStyle/>
+          <a:p>
+            <a:pPr algn="ctr"/>
+          </a:p>
+        </p:txBody>
+      </p:sp>
+      <p:sp>
+        <p:nvSpPr>
+          <p:cNvPr id="21" name="TextBox 20"/>
+          <p:cNvSpPr txBox="1"/>
+          <p:nvPr/>
+        </p:nvSpPr>
+        <p:spPr>
+          <a:xfrm>
+            <a:off x="644400" y="5475600"/>
+            <a:ext cx="10065600" cy="136800"/>
+          </a:xfrm>
+          <a:prstGeom prst="rect">
+            <a:avLst/>
+          </a:prstGeom>
+          <a:noFill/>
+        </p:spPr>
+        <p:txBody>
+          <a:bodyPr wrap="square" lIns="0" tIns="0" rIns="0" bIns="0" anchor="t">
+            <a:spAutoFit/>
+          </a:bodyPr>
+          <a:lstStyle/>
+          <a:p>
+            <a:pPr algn="l">
+              <a:lnSpc>
+                <a:spcPct val="107000"/>
+              </a:lnSpc>
+            </a:pPr>
+            <a:r>
+              <a:rPr sz="840" b="0">
+                <a:solidFill>
+                  <a:srgbClr val="0A0A0A"/>
+                </a:solidFill>
+                <a:latin typeface="Microsoft YaHei"/>
+              </a:rPr>
+              <a:t>选择依据：前 5 个主成分累计解释约 98.3% 方差，兼顾信息保留和训练难度。</a:t>
+            </a:r>
+          </a:p>
+        </p:txBody>
+      </p:sp>
+      <p:sp>
+        <p:nvSpPr>
+          <p:cNvPr id="22" name="TextBox 21"/>
           <p:cNvSpPr txBox="1"/>
           <p:nvPr/>
         </p:nvSpPr>
@@ -10242,7 +12079,7 @@
       </p:sp>
       <p:sp>
         <p:nvSpPr>
-          <p:cNvPr id="15" name="TextBox 14"/>
+          <p:cNvPr id="23" name="TextBox 22"/>
           <p:cNvSpPr txBox="1"/>
           <p:nvPr/>
         </p:nvSpPr>
@@ -10473,9 +12310,298 @@
           </a:p>
         </p:txBody>
       </p:sp>
+      <p:sp>
+        <p:nvSpPr>
+          <p:cNvPr id="7" name="Rectangle 6"/>
+          <p:cNvSpPr/>
+          <p:nvPr/>
+        </p:nvSpPr>
+        <p:spPr>
+          <a:xfrm>
+            <a:off x="360000" y="3690000"/>
+            <a:ext cx="7020000" cy="720000"/>
+          </a:xfrm>
+          <a:prstGeom prst="rect">
+            <a:avLst/>
+          </a:prstGeom>
+          <a:solidFill>
+            <a:srgbClr val="F0F0EE"/>
+          </a:solidFill>
+          <a:ln>
+            <a:noFill/>
+          </a:ln>
+        </p:spPr>
+        <p:style>
+          <a:lnRef idx="1">
+            <a:schemeClr val="accent1"/>
+          </a:lnRef>
+          <a:fillRef idx="3">
+            <a:schemeClr val="accent1"/>
+          </a:fillRef>
+          <a:effectRef idx="2">
+            <a:schemeClr val="accent1"/>
+          </a:effectRef>
+          <a:fontRef idx="minor">
+            <a:schemeClr val="lt1"/>
+          </a:fontRef>
+        </p:style>
+        <p:txBody>
+          <a:bodyPr rtlCol="0" anchor="ctr"/>
+          <a:lstStyle/>
+          <a:p>
+            <a:pPr algn="ctr"/>
+          </a:p>
+        </p:txBody>
+      </p:sp>
+      <p:sp>
+        <p:nvSpPr>
+          <p:cNvPr id="8" name="Rectangle 7"/>
+          <p:cNvSpPr/>
+          <p:nvPr/>
+        </p:nvSpPr>
+        <p:spPr>
+          <a:xfrm>
+            <a:off x="522000" y="3902400"/>
+            <a:ext cx="46800" cy="46800"/>
+          </a:xfrm>
+          <a:prstGeom prst="rect">
+            <a:avLst/>
+          </a:prstGeom>
+          <a:solidFill>
+            <a:srgbClr val="002FA7"/>
+          </a:solidFill>
+          <a:ln>
+            <a:noFill/>
+          </a:ln>
+        </p:spPr>
+        <p:style>
+          <a:lnRef idx="1">
+            <a:schemeClr val="accent1"/>
+          </a:lnRef>
+          <a:fillRef idx="3">
+            <a:schemeClr val="accent1"/>
+          </a:fillRef>
+          <a:effectRef idx="2">
+            <a:schemeClr val="accent1"/>
+          </a:effectRef>
+          <a:fontRef idx="minor">
+            <a:schemeClr val="lt1"/>
+          </a:fontRef>
+        </p:style>
+        <p:txBody>
+          <a:bodyPr rtlCol="0" anchor="ctr"/>
+          <a:lstStyle/>
+          <a:p>
+            <a:pPr algn="ctr"/>
+          </a:p>
+        </p:txBody>
+      </p:sp>
+      <p:sp>
+        <p:nvSpPr>
+          <p:cNvPr id="9" name="TextBox 8"/>
+          <p:cNvSpPr txBox="1"/>
+          <p:nvPr/>
+        </p:nvSpPr>
+        <p:spPr>
+          <a:xfrm>
+            <a:off x="644400" y="3844800"/>
+            <a:ext cx="6537600" cy="169200"/>
+          </a:xfrm>
+          <a:prstGeom prst="rect">
+            <a:avLst/>
+          </a:prstGeom>
+          <a:noFill/>
+        </p:spPr>
+        <p:txBody>
+          <a:bodyPr wrap="square" lIns="0" tIns="0" rIns="0" bIns="0" anchor="t">
+            <a:spAutoFit/>
+          </a:bodyPr>
+          <a:lstStyle/>
+          <a:p>
+            <a:pPr algn="l">
+              <a:lnSpc>
+                <a:spcPct val="107000"/>
+              </a:lnSpc>
+            </a:pPr>
+            <a:r>
+              <a:rPr sz="860" b="0">
+                <a:solidFill>
+                  <a:srgbClr val="0A0A0A"/>
+                </a:solidFill>
+                <a:latin typeface="Microsoft YaHei"/>
+              </a:rPr>
+              <a:t>MAE 表示平均偏差；RMSE 对较大误差更敏感；R² 反映解释能力。</a:t>
+            </a:r>
+          </a:p>
+        </p:txBody>
+      </p:sp>
+      <p:sp>
+        <p:nvSpPr>
+          <p:cNvPr id="10" name="Rectangle 9"/>
+          <p:cNvSpPr/>
+          <p:nvPr/>
+        </p:nvSpPr>
+        <p:spPr>
+          <a:xfrm>
+            <a:off x="522000" y="4071600"/>
+            <a:ext cx="46800" cy="46800"/>
+          </a:xfrm>
+          <a:prstGeom prst="rect">
+            <a:avLst/>
+          </a:prstGeom>
+          <a:solidFill>
+            <a:srgbClr val="002FA7"/>
+          </a:solidFill>
+          <a:ln>
+            <a:noFill/>
+          </a:ln>
+        </p:spPr>
+        <p:style>
+          <a:lnRef idx="1">
+            <a:schemeClr val="accent1"/>
+          </a:lnRef>
+          <a:fillRef idx="3">
+            <a:schemeClr val="accent1"/>
+          </a:fillRef>
+          <a:effectRef idx="2">
+            <a:schemeClr val="accent1"/>
+          </a:effectRef>
+          <a:fontRef idx="minor">
+            <a:schemeClr val="lt1"/>
+          </a:fontRef>
+        </p:style>
+        <p:txBody>
+          <a:bodyPr rtlCol="0" anchor="ctr"/>
+          <a:lstStyle/>
+          <a:p>
+            <a:pPr algn="ctr"/>
+          </a:p>
+        </p:txBody>
+      </p:sp>
+      <p:sp>
+        <p:nvSpPr>
+          <p:cNvPr id="11" name="TextBox 10"/>
+          <p:cNvSpPr txBox="1"/>
+          <p:nvPr/>
+        </p:nvSpPr>
+        <p:spPr>
+          <a:xfrm>
+            <a:off x="644400" y="4014000"/>
+            <a:ext cx="6537600" cy="169200"/>
+          </a:xfrm>
+          <a:prstGeom prst="rect">
+            <a:avLst/>
+          </a:prstGeom>
+          <a:noFill/>
+        </p:spPr>
+        <p:txBody>
+          <a:bodyPr wrap="square" lIns="0" tIns="0" rIns="0" bIns="0" anchor="t">
+            <a:spAutoFit/>
+          </a:bodyPr>
+          <a:lstStyle/>
+          <a:p>
+            <a:pPr algn="l">
+              <a:lnSpc>
+                <a:spcPct val="107000"/>
+              </a:lnSpc>
+            </a:pPr>
+            <a:r>
+              <a:rPr sz="860" b="0">
+                <a:solidFill>
+                  <a:srgbClr val="0A0A0A"/>
+                </a:solidFill>
+                <a:latin typeface="Microsoft YaHei"/>
+              </a:rPr>
+              <a:t>五个模型输入和输出完全一致，因此比较的是模型本身的拟合能力。</a:t>
+            </a:r>
+          </a:p>
+        </p:txBody>
+      </p:sp>
+      <p:sp>
+        <p:nvSpPr>
+          <p:cNvPr id="12" name="Rectangle 11"/>
+          <p:cNvSpPr/>
+          <p:nvPr/>
+        </p:nvSpPr>
+        <p:spPr>
+          <a:xfrm>
+            <a:off x="522000" y="4240800"/>
+            <a:ext cx="46800" cy="46800"/>
+          </a:xfrm>
+          <a:prstGeom prst="rect">
+            <a:avLst/>
+          </a:prstGeom>
+          <a:solidFill>
+            <a:srgbClr val="002FA7"/>
+          </a:solidFill>
+          <a:ln>
+            <a:noFill/>
+          </a:ln>
+        </p:spPr>
+        <p:style>
+          <a:lnRef idx="1">
+            <a:schemeClr val="accent1"/>
+          </a:lnRef>
+          <a:fillRef idx="3">
+            <a:schemeClr val="accent1"/>
+          </a:fillRef>
+          <a:effectRef idx="2">
+            <a:schemeClr val="accent1"/>
+          </a:effectRef>
+          <a:fontRef idx="minor">
+            <a:schemeClr val="lt1"/>
+          </a:fontRef>
+        </p:style>
+        <p:txBody>
+          <a:bodyPr rtlCol="0" anchor="ctr"/>
+          <a:lstStyle/>
+          <a:p>
+            <a:pPr algn="ctr"/>
+          </a:p>
+        </p:txBody>
+      </p:sp>
+      <p:sp>
+        <p:nvSpPr>
+          <p:cNvPr id="13" name="TextBox 12"/>
+          <p:cNvSpPr txBox="1"/>
+          <p:nvPr/>
+        </p:nvSpPr>
+        <p:spPr>
+          <a:xfrm>
+            <a:off x="644400" y="4183199"/>
+            <a:ext cx="6537600" cy="169200"/>
+          </a:xfrm>
+          <a:prstGeom prst="rect">
+            <a:avLst/>
+          </a:prstGeom>
+          <a:noFill/>
+        </p:spPr>
+        <p:txBody>
+          <a:bodyPr wrap="square" lIns="0" tIns="0" rIns="0" bIns="0" anchor="t">
+            <a:spAutoFit/>
+          </a:bodyPr>
+          <a:lstStyle/>
+          <a:p>
+            <a:pPr algn="l">
+              <a:lnSpc>
+                <a:spcPct val="107000"/>
+              </a:lnSpc>
+            </a:pPr>
+            <a:r>
+              <a:rPr sz="860" b="0">
+                <a:solidFill>
+                  <a:srgbClr val="0A0A0A"/>
+                </a:solidFill>
+                <a:latin typeface="Microsoft YaHei"/>
+              </a:rPr>
+              <a:t>选择模型时不只看 R²，也要结合 RMSE、训练成本和预测稳定性。</a:t>
+            </a:r>
+          </a:p>
+        </p:txBody>
+      </p:sp>
       <p:graphicFrame>
         <p:nvGraphicFramePr>
-          <p:cNvPr id="7" name="Table 6"/>
+          <p:cNvPr id="14" name="Table 13"/>
           <p:cNvGraphicFramePr>
             <a:graphicFrameLocks noGrp="1"/>
           </p:cNvGraphicFramePr>
@@ -11206,7 +13332,7 @@
       </p:graphicFrame>
       <p:sp>
         <p:nvSpPr>
-          <p:cNvPr id="8" name="Rectangle 7"/>
+          <p:cNvPr id="15" name="Rectangle 14"/>
           <p:cNvSpPr/>
           <p:nvPr/>
         </p:nvSpPr>
@@ -11249,7 +13375,7 @@
       </p:sp>
       <p:sp>
         <p:nvSpPr>
-          <p:cNvPr id="9" name="TextBox 8"/>
+          <p:cNvPr id="16" name="TextBox 15"/>
           <p:cNvSpPr txBox="1"/>
           <p:nvPr/>
         </p:nvSpPr>
@@ -11284,14 +13410,14 @@
       </p:sp>
       <p:sp>
         <p:nvSpPr>
-          <p:cNvPr id="10" name="TextBox 9"/>
-          <p:cNvSpPr txBox="1"/>
-          <p:nvPr/>
-        </p:nvSpPr>
-        <p:spPr>
-          <a:xfrm>
-            <a:off x="7830000" y="3528000"/>
-            <a:ext cx="3150000" cy="273600"/>
+          <p:cNvPr id="17" name="TextBox 16"/>
+          <p:cNvSpPr txBox="1"/>
+          <p:nvPr/>
+        </p:nvSpPr>
+        <p:spPr>
+          <a:xfrm>
+            <a:off x="7830000" y="3484800"/>
+            <a:ext cx="3150000" cy="378000"/>
           </a:xfrm>
           <a:prstGeom prst="rect">
             <a:avLst/>
@@ -11310,20 +13436,153 @@
               </a:lnSpc>
             </a:pPr>
             <a:r>
-              <a:rPr sz="860" b="0">
+              <a:rPr sz="810" b="0">
                 <a:solidFill>
                   <a:srgbClr val="FFFFFF"/>
                 </a:solidFill>
                 <a:latin typeface="Microsoft YaHei"/>
               </a:rPr>
-              <a:t>KNN 的 MAE 略低，但 RMSE 与预测耗时不占优；MLP 的 R² 略高，但误差更大，稳定性也更敏感。</a:t>
-            </a:r>
-          </a:p>
-        </p:txBody>
-      </p:sp>
-      <p:sp>
-        <p:nvSpPr>
-          <p:cNvPr id="11" name="TextBox 10"/>
+              <a:t>随机森林 RMSE 最小，综合稳定性更好。</a:t>
+            </a:r>
+          </a:p>
+          <a:p>
+            <a:pPr algn="l">
+              <a:lnSpc>
+                <a:spcPct val="100000"/>
+              </a:lnSpc>
+            </a:pPr>
+            <a:r>
+              <a:rPr sz="810" b="0">
+                <a:solidFill>
+                  <a:srgbClr val="FFFFFF"/>
+                </a:solidFill>
+                <a:latin typeface="Microsoft YaHei"/>
+              </a:rPr>
+              <a:t>KNN 的 MAE 略低，但 RMSE 与预测耗时不占优；MLP 的 R² 略高，但误差更大。</a:t>
+            </a:r>
+          </a:p>
+        </p:txBody>
+      </p:sp>
+      <p:sp>
+        <p:nvSpPr>
+          <p:cNvPr id="18" name="Rectangle 17"/>
+          <p:cNvSpPr/>
+          <p:nvPr/>
+        </p:nvSpPr>
+        <p:spPr>
+          <a:xfrm>
+            <a:off x="360000" y="4572000"/>
+            <a:ext cx="10836000" cy="558000"/>
+          </a:xfrm>
+          <a:prstGeom prst="rect">
+            <a:avLst/>
+          </a:prstGeom>
+          <a:solidFill>
+            <a:srgbClr val="FAFAF8"/>
+          </a:solidFill>
+          <a:ln>
+            <a:noFill/>
+          </a:ln>
+        </p:spPr>
+        <p:style>
+          <a:lnRef idx="1">
+            <a:schemeClr val="accent1"/>
+          </a:lnRef>
+          <a:fillRef idx="3">
+            <a:schemeClr val="accent1"/>
+          </a:fillRef>
+          <a:effectRef idx="2">
+            <a:schemeClr val="accent1"/>
+          </a:effectRef>
+          <a:fontRef idx="minor">
+            <a:schemeClr val="lt1"/>
+          </a:fontRef>
+        </p:style>
+        <p:txBody>
+          <a:bodyPr rtlCol="0" anchor="ctr"/>
+          <a:lstStyle/>
+          <a:p>
+            <a:pPr algn="ctr"/>
+          </a:p>
+        </p:txBody>
+      </p:sp>
+      <p:sp>
+        <p:nvSpPr>
+          <p:cNvPr id="19" name="TextBox 18"/>
+          <p:cNvSpPr txBox="1"/>
+          <p:nvPr/>
+        </p:nvSpPr>
+        <p:spPr>
+          <a:xfrm>
+            <a:off x="486000" y="4662000"/>
+            <a:ext cx="10584000" cy="122400"/>
+          </a:xfrm>
+          <a:prstGeom prst="rect">
+            <a:avLst/>
+          </a:prstGeom>
+          <a:noFill/>
+        </p:spPr>
+        <p:txBody>
+          <a:bodyPr wrap="square" lIns="0" tIns="0" rIns="0" bIns="0" anchor="t">
+            <a:spAutoFit/>
+          </a:bodyPr>
+          <a:lstStyle/>
+          <a:p>
+            <a:pPr algn="l"/>
+            <a:r>
+              <a:rPr sz="940" b="1">
+                <a:solidFill>
+                  <a:srgbClr val="002FA7"/>
+                </a:solidFill>
+                <a:latin typeface="Microsoft YaHei"/>
+              </a:rPr>
+              <a:t>模型选择结论</a:t>
+            </a:r>
+          </a:p>
+        </p:txBody>
+      </p:sp>
+      <p:sp>
+        <p:nvSpPr>
+          <p:cNvPr id="20" name="TextBox 19"/>
+          <p:cNvSpPr txBox="1"/>
+          <p:nvPr/>
+        </p:nvSpPr>
+        <p:spPr>
+          <a:xfrm>
+            <a:off x="486000" y="4852799"/>
+            <a:ext cx="10584000" cy="226800"/>
+          </a:xfrm>
+          <a:prstGeom prst="rect">
+            <a:avLst/>
+          </a:prstGeom>
+          <a:noFill/>
+        </p:spPr>
+        <p:txBody>
+          <a:bodyPr wrap="square" lIns="0" tIns="0" rIns="0" bIns="0" anchor="t">
+            <a:spAutoFit/>
+          </a:bodyPr>
+          <a:lstStyle/>
+          <a:p>
+            <a:pPr algn="l">
+              <a:lnSpc>
+                <a:spcPct val="103000"/>
+              </a:lnSpc>
+            </a:pPr>
+            <a:r>
+              <a:rPr sz="869" b="0">
+                <a:solidFill>
+                  <a:srgbClr val="0A0A0A"/>
+                </a:solidFill>
+                <a:latin typeface="Microsoft YaHei"/>
+              </a:rPr>
+              <a:t>线性回归明显落后，说明环境特征到光谱形状不是简单线性关系。单棵决策树也不如随机森林，体现了集成模型在稳定性上的优势。</a:t>
+            </a:r>
+          </a:p>
+        </p:txBody>
+      </p:sp>
+      <p:sp>
+        <p:nvSpPr>
+          <p:cNvPr id="21" name="TextBox 20"/>
           <p:cNvSpPr txBox="1"/>
           <p:nvPr/>
         </p:nvSpPr>
@@ -11358,7 +13617,7 @@
       </p:sp>
       <p:sp>
         <p:nvSpPr>
-          <p:cNvPr id="12" name="TextBox 11"/>
+          <p:cNvPr id="22" name="TextBox 21"/>
           <p:cNvSpPr txBox="1"/>
           <p:nvPr/>
         </p:nvSpPr>
@@ -12095,7 +14354,206 @@
       </p:sp>
       <p:sp>
         <p:nvSpPr>
-          <p:cNvPr id="19" name="TextBox 18"/>
+          <p:cNvPr id="19" name="Rectangle 18"/>
+          <p:cNvSpPr/>
+          <p:nvPr/>
+        </p:nvSpPr>
+        <p:spPr>
+          <a:xfrm>
+            <a:off x="8316000" y="4384800"/>
+            <a:ext cx="2880000" cy="511200"/>
+          </a:xfrm>
+          <a:prstGeom prst="rect">
+            <a:avLst/>
+          </a:prstGeom>
+          <a:solidFill>
+            <a:srgbClr val="F0F0EE"/>
+          </a:solidFill>
+          <a:ln>
+            <a:noFill/>
+          </a:ln>
+        </p:spPr>
+        <p:style>
+          <a:lnRef idx="1">
+            <a:schemeClr val="accent1"/>
+          </a:lnRef>
+          <a:fillRef idx="3">
+            <a:schemeClr val="accent1"/>
+          </a:fillRef>
+          <a:effectRef idx="2">
+            <a:schemeClr val="accent1"/>
+          </a:effectRef>
+          <a:fontRef idx="minor">
+            <a:schemeClr val="lt1"/>
+          </a:fontRef>
+        </p:style>
+        <p:txBody>
+          <a:bodyPr rtlCol="0" anchor="ctr"/>
+          <a:lstStyle/>
+          <a:p>
+            <a:pPr algn="ctr"/>
+          </a:p>
+        </p:txBody>
+      </p:sp>
+      <p:sp>
+        <p:nvSpPr>
+          <p:cNvPr id="20" name="TextBox 19"/>
+          <p:cNvSpPr txBox="1"/>
+          <p:nvPr/>
+        </p:nvSpPr>
+        <p:spPr>
+          <a:xfrm>
+            <a:off x="8478000" y="4500000"/>
+            <a:ext cx="2556000" cy="198000"/>
+          </a:xfrm>
+          <a:prstGeom prst="rect">
+            <a:avLst/>
+          </a:prstGeom>
+          <a:noFill/>
+        </p:spPr>
+        <p:txBody>
+          <a:bodyPr wrap="square" lIns="0" tIns="0" rIns="0" bIns="0" anchor="t">
+            <a:spAutoFit/>
+          </a:bodyPr>
+          <a:lstStyle/>
+          <a:p>
+            <a:pPr algn="l">
+              <a:lnSpc>
+                <a:spcPct val="100000"/>
+              </a:lnSpc>
+            </a:pPr>
+            <a:r>
+              <a:rPr sz="850" b="1">
+                <a:solidFill>
+                  <a:srgbClr val="0A0A0A"/>
+                </a:solidFill>
+                <a:latin typeface="Microsoft YaHei"/>
+              </a:rPr>
+              <a:t>结果边界：预测的是相对光谱形状，不能替代现场光谱仪的绝对测量。</a:t>
+            </a:r>
+          </a:p>
+        </p:txBody>
+      </p:sp>
+      <p:sp>
+        <p:nvSpPr>
+          <p:cNvPr id="21" name="Rectangle 20"/>
+          <p:cNvSpPr/>
+          <p:nvPr/>
+        </p:nvSpPr>
+        <p:spPr>
+          <a:xfrm>
+            <a:off x="360000" y="5382000"/>
+            <a:ext cx="7632000" cy="450000"/>
+          </a:xfrm>
+          <a:prstGeom prst="rect">
+            <a:avLst/>
+          </a:prstGeom>
+          <a:solidFill>
+            <a:srgbClr val="F0F0EE"/>
+          </a:solidFill>
+          <a:ln>
+            <a:noFill/>
+          </a:ln>
+        </p:spPr>
+        <p:style>
+          <a:lnRef idx="1">
+            <a:schemeClr val="accent1"/>
+          </a:lnRef>
+          <a:fillRef idx="3">
+            <a:schemeClr val="accent1"/>
+          </a:fillRef>
+          <a:effectRef idx="2">
+            <a:schemeClr val="accent1"/>
+          </a:effectRef>
+          <a:fontRef idx="minor">
+            <a:schemeClr val="lt1"/>
+          </a:fontRef>
+        </p:style>
+        <p:txBody>
+          <a:bodyPr rtlCol="0" anchor="ctr"/>
+          <a:lstStyle/>
+          <a:p>
+            <a:pPr algn="ctr"/>
+          </a:p>
+        </p:txBody>
+      </p:sp>
+      <p:sp>
+        <p:nvSpPr>
+          <p:cNvPr id="22" name="TextBox 21"/>
+          <p:cNvSpPr txBox="1"/>
+          <p:nvPr/>
+        </p:nvSpPr>
+        <p:spPr>
+          <a:xfrm>
+            <a:off x="486000" y="5472000"/>
+            <a:ext cx="7380000" cy="122400"/>
+          </a:xfrm>
+          <a:prstGeom prst="rect">
+            <a:avLst/>
+          </a:prstGeom>
+          <a:noFill/>
+        </p:spPr>
+        <p:txBody>
+          <a:bodyPr wrap="square" lIns="0" tIns="0" rIns="0" bIns="0" anchor="t">
+            <a:spAutoFit/>
+          </a:bodyPr>
+          <a:lstStyle/>
+          <a:p>
+            <a:pPr algn="l"/>
+            <a:r>
+              <a:rPr sz="940" b="1">
+                <a:solidFill>
+                  <a:srgbClr val="002FA7"/>
+                </a:solidFill>
+                <a:latin typeface="Microsoft YaHei"/>
+              </a:rPr>
+              <a:t>结果解读</a:t>
+            </a:r>
+          </a:p>
+        </p:txBody>
+      </p:sp>
+      <p:sp>
+        <p:nvSpPr>
+          <p:cNvPr id="23" name="TextBox 22"/>
+          <p:cNvSpPr txBox="1"/>
+          <p:nvPr/>
+        </p:nvSpPr>
+        <p:spPr>
+          <a:xfrm>
+            <a:off x="486000" y="5662799"/>
+            <a:ext cx="7380000" cy="118799"/>
+          </a:xfrm>
+          <a:prstGeom prst="rect">
+            <a:avLst/>
+          </a:prstGeom>
+          <a:noFill/>
+        </p:spPr>
+        <p:txBody>
+          <a:bodyPr wrap="square" lIns="0" tIns="0" rIns="0" bIns="0" anchor="t">
+            <a:spAutoFit/>
+          </a:bodyPr>
+          <a:lstStyle/>
+          <a:p>
+            <a:pPr algn="l">
+              <a:lnSpc>
+                <a:spcPct val="103000"/>
+              </a:lnSpc>
+            </a:pPr>
+            <a:r>
+              <a:rPr sz="869" b="0">
+                <a:solidFill>
+                  <a:srgbClr val="0A0A0A"/>
+                </a:solidFill>
+                <a:latin typeface="Microsoft YaHei"/>
+              </a:rPr>
+              <a:t>图中两条线越接近，说明还原后的光谱形状越接近实测结果。这里不是证明模型永远准确，而是说明在测试样本上，它能抓住自然光光谱的主要起伏。</a:t>
+            </a:r>
+          </a:p>
+        </p:txBody>
+      </p:sp>
+      <p:sp>
+        <p:nvSpPr>
+          <p:cNvPr id="24" name="TextBox 23"/>
           <p:cNvSpPr txBox="1"/>
           <p:nvPr/>
         </p:nvSpPr>
@@ -12130,7 +14588,7 @@
       </p:sp>
       <p:sp>
         <p:nvSpPr>
-          <p:cNvPr id="20" name="TextBox 19"/>
+          <p:cNvPr id="25" name="TextBox 24"/>
           <p:cNvSpPr txBox="1"/>
           <p:nvPr/>
         </p:nvSpPr>
@@ -12165,7 +14623,7 @@
       </p:sp>
       <p:sp>
         <p:nvSpPr>
-          <p:cNvPr id="21" name="TextBox 20"/>
+          <p:cNvPr id="26" name="TextBox 25"/>
           <p:cNvSpPr txBox="1"/>
           <p:nvPr/>
         </p:nvSpPr>
@@ -12482,8 +14940,8 @@
         </p:nvSpPr>
         <p:spPr>
           <a:xfrm>
-            <a:off x="8226000" y="1198800"/>
-            <a:ext cx="2772000" cy="360000"/>
+            <a:off x="8226000" y="1123200"/>
+            <a:ext cx="2772000" cy="352800"/>
           </a:xfrm>
           <a:prstGeom prst="rect">
             <a:avLst/>
@@ -12502,7 +14960,7 @@
               </a:lnSpc>
             </a:pPr>
             <a:r>
-              <a:rPr sz="1100" b="1">
+              <a:rPr sz="1030" b="1">
                 <a:solidFill>
                   <a:srgbClr val="0A0A0A"/>
                 </a:solidFill>
@@ -12518,7 +14976,7 @@
               </a:lnSpc>
             </a:pPr>
             <a:r>
-              <a:rPr sz="1100" b="1">
+              <a:rPr sz="1030" b="1">
                 <a:solidFill>
                   <a:srgbClr val="0A0A0A"/>
                 </a:solidFill>
@@ -12537,8 +14995,8 @@
         </p:nvSpPr>
         <p:spPr>
           <a:xfrm>
-            <a:off x="8226000" y="1710000"/>
-            <a:ext cx="2772000" cy="306000"/>
+            <a:off x="8226000" y="1591200"/>
+            <a:ext cx="2772000" cy="342000"/>
           </a:xfrm>
           <a:prstGeom prst="rect">
             <a:avLst/>
@@ -12553,24 +15011,75 @@
           <a:p>
             <a:pPr algn="l">
               <a:lnSpc>
-                <a:spcPct val="105000"/>
+                <a:spcPct val="100000"/>
               </a:lnSpc>
             </a:pPr>
             <a:r>
-              <a:rPr sz="900" b="0">
+              <a:rPr sz="810" b="0">
                 <a:solidFill>
                   <a:srgbClr val="0A0A0A"/>
                 </a:solidFill>
                 <a:latin typeface="Microsoft YaHei"/>
               </a:rPr>
-              <a:t>用非负最小二乘计算 LED 通道比例，使自然光 + 人工光尽量接近目标光谱。</a:t>
-            </a:r>
-          </a:p>
-        </p:txBody>
-      </p:sp>
-      <p:sp>
-        <p:nvSpPr>
-          <p:cNvPr id="11" name="Rectangle 10"/>
+              <a:t>图表解读：黑线目标、蓝虚线自然光、</a:t>
+            </a:r>
+          </a:p>
+          <a:p>
+            <a:pPr algn="l">
+              <a:lnSpc>
+                <a:spcPct val="100000"/>
+              </a:lnSpc>
+            </a:pPr>
+            <a:r>
+              <a:rPr sz="810" b="0">
+                <a:solidFill>
+                  <a:srgbClr val="0A0A0A"/>
+                </a:solidFill>
+                <a:latin typeface="Microsoft YaHei"/>
+              </a:rPr>
+              <a:t>绿线多通道补偿、橙线传统双色温。</a:t>
+            </a:r>
+          </a:p>
+        </p:txBody>
+      </p:sp>
+      <p:sp>
+        <p:nvSpPr>
+          <p:cNvPr id="11" name="TextBox 10"/>
+          <p:cNvSpPr txBox="1"/>
+          <p:nvPr/>
+        </p:nvSpPr>
+        <p:spPr>
+          <a:xfrm>
+            <a:off x="8226000" y="2095200"/>
+            <a:ext cx="2772000" cy="136800"/>
+          </a:xfrm>
+          <a:prstGeom prst="rect">
+            <a:avLst/>
+          </a:prstGeom>
+          <a:noFill/>
+        </p:spPr>
+        <p:txBody>
+          <a:bodyPr wrap="square" lIns="0" tIns="0" rIns="0" bIns="0" anchor="t">
+            <a:spAutoFit/>
+          </a:bodyPr>
+          <a:lstStyle/>
+          <a:p>
+            <a:pPr algn="l"/>
+            <a:r>
+              <a:rPr sz="830" b="0">
+                <a:solidFill>
+                  <a:srgbClr val="737373"/>
+                </a:solidFill>
+                <a:latin typeface="Microsoft YaHei"/>
+              </a:rPr>
+              <a:t>算法：非负最小二乘求 7 通道比例。</a:t>
+            </a:r>
+          </a:p>
+        </p:txBody>
+      </p:sp>
+      <p:sp>
+        <p:nvSpPr>
+          <p:cNvPr id="12" name="Rectangle 11"/>
           <p:cNvSpPr/>
           <p:nvPr/>
         </p:nvSpPr>
@@ -12613,7 +15122,7 @@
       </p:sp>
       <p:sp>
         <p:nvSpPr>
-          <p:cNvPr id="12" name="TextBox 11"/>
+          <p:cNvPr id="13" name="TextBox 12"/>
           <p:cNvSpPr txBox="1"/>
           <p:nvPr/>
         </p:nvSpPr>
@@ -12648,7 +15157,7 @@
       </p:sp>
       <p:sp>
         <p:nvSpPr>
-          <p:cNvPr id="13" name="TextBox 12"/>
+          <p:cNvPr id="14" name="TextBox 13"/>
           <p:cNvSpPr txBox="1"/>
           <p:nvPr/>
         </p:nvSpPr>
@@ -12735,7 +15244,159 @@
       </p:sp>
       <p:sp>
         <p:nvSpPr>
-          <p:cNvPr id="14" name="TextBox 13"/>
+          <p:cNvPr id="15" name="TextBox 14"/>
+          <p:cNvSpPr txBox="1"/>
+          <p:nvPr/>
+        </p:nvSpPr>
+        <p:spPr>
+          <a:xfrm>
+            <a:off x="8226000" y="4626000"/>
+            <a:ext cx="2736000" cy="187200"/>
+          </a:xfrm>
+          <a:prstGeom prst="rect">
+            <a:avLst/>
+          </a:prstGeom>
+          <a:noFill/>
+        </p:spPr>
+        <p:txBody>
+          <a:bodyPr wrap="square" lIns="0" tIns="0" rIns="0" bIns="0" anchor="t">
+            <a:spAutoFit/>
+          </a:bodyPr>
+          <a:lstStyle/>
+          <a:p>
+            <a:pPr algn="l"/>
+            <a:r>
+              <a:rPr sz="840" b="1">
+                <a:solidFill>
+                  <a:srgbClr val="737373"/>
+                </a:solidFill>
+                <a:latin typeface="Microsoft YaHei"/>
+              </a:rPr>
+              <a:t>课程定位：这里展示的是算法设计方案，暂未接入真实灯具硬件。</a:t>
+            </a:r>
+          </a:p>
+        </p:txBody>
+      </p:sp>
+      <p:sp>
+        <p:nvSpPr>
+          <p:cNvPr id="16" name="Rectangle 15"/>
+          <p:cNvSpPr/>
+          <p:nvPr/>
+        </p:nvSpPr>
+        <p:spPr>
+          <a:xfrm>
+            <a:off x="360000" y="5382000"/>
+            <a:ext cx="7452000" cy="450000"/>
+          </a:xfrm>
+          <a:prstGeom prst="rect">
+            <a:avLst/>
+          </a:prstGeom>
+          <a:solidFill>
+            <a:srgbClr val="F0F0EE"/>
+          </a:solidFill>
+          <a:ln>
+            <a:noFill/>
+          </a:ln>
+        </p:spPr>
+        <p:style>
+          <a:lnRef idx="1">
+            <a:schemeClr val="accent1"/>
+          </a:lnRef>
+          <a:fillRef idx="3">
+            <a:schemeClr val="accent1"/>
+          </a:fillRef>
+          <a:effectRef idx="2">
+            <a:schemeClr val="accent1"/>
+          </a:effectRef>
+          <a:fontRef idx="minor">
+            <a:schemeClr val="lt1"/>
+          </a:fontRef>
+        </p:style>
+        <p:txBody>
+          <a:bodyPr rtlCol="0" anchor="ctr"/>
+          <a:lstStyle/>
+          <a:p>
+            <a:pPr algn="ctr"/>
+          </a:p>
+        </p:txBody>
+      </p:sp>
+      <p:sp>
+        <p:nvSpPr>
+          <p:cNvPr id="17" name="TextBox 16"/>
+          <p:cNvSpPr txBox="1"/>
+          <p:nvPr/>
+        </p:nvSpPr>
+        <p:spPr>
+          <a:xfrm>
+            <a:off x="486000" y="5472000"/>
+            <a:ext cx="7200000" cy="122400"/>
+          </a:xfrm>
+          <a:prstGeom prst="rect">
+            <a:avLst/>
+          </a:prstGeom>
+          <a:noFill/>
+        </p:spPr>
+        <p:txBody>
+          <a:bodyPr wrap="square" lIns="0" tIns="0" rIns="0" bIns="0" anchor="t">
+            <a:spAutoFit/>
+          </a:bodyPr>
+          <a:lstStyle/>
+          <a:p>
+            <a:pPr algn="l"/>
+            <a:r>
+              <a:rPr sz="940" b="1">
+                <a:solidFill>
+                  <a:srgbClr val="002FA7"/>
+                </a:solidFill>
+                <a:latin typeface="Microsoft YaHei"/>
+              </a:rPr>
+              <a:t>补偿结论</a:t>
+            </a:r>
+          </a:p>
+        </p:txBody>
+      </p:sp>
+      <p:sp>
+        <p:nvSpPr>
+          <p:cNvPr id="18" name="TextBox 17"/>
+          <p:cNvSpPr txBox="1"/>
+          <p:nvPr/>
+        </p:nvSpPr>
+        <p:spPr>
+          <a:xfrm>
+            <a:off x="486000" y="5662799"/>
+            <a:ext cx="7200000" cy="118799"/>
+          </a:xfrm>
+          <a:prstGeom prst="rect">
+            <a:avLst/>
+          </a:prstGeom>
+          <a:noFill/>
+        </p:spPr>
+        <p:txBody>
+          <a:bodyPr wrap="square" lIns="0" tIns="0" rIns="0" bIns="0" anchor="t">
+            <a:spAutoFit/>
+          </a:bodyPr>
+          <a:lstStyle/>
+          <a:p>
+            <a:pPr algn="l">
+              <a:lnSpc>
+                <a:spcPct val="103000"/>
+              </a:lnSpc>
+            </a:pPr>
+            <a:r>
+              <a:rPr sz="869" b="0">
+                <a:solidFill>
+                  <a:srgbClr val="0A0A0A"/>
+                </a:solidFill>
+                <a:latin typeface="Microsoft YaHei"/>
+              </a:rPr>
+              <a:t>多通道 LED 的优势在于自由度更多：不同波段可以分别补。传统双色温方案主要改变冷暖比例，因此在某些波段会更难贴近目标光谱。</a:t>
+            </a:r>
+          </a:p>
+        </p:txBody>
+      </p:sp>
+      <p:sp>
+        <p:nvSpPr>
+          <p:cNvPr id="19" name="TextBox 18"/>
           <p:cNvSpPr txBox="1"/>
           <p:nvPr/>
         </p:nvSpPr>
@@ -12770,7 +15431,7 @@
       </p:sp>
       <p:sp>
         <p:nvSpPr>
-          <p:cNvPr id="15" name="TextBox 14"/>
+          <p:cNvPr id="20" name="TextBox 19"/>
           <p:cNvSpPr txBox="1"/>
           <p:nvPr/>
         </p:nvSpPr>

</xml_diff>